<commit_message>
Rebuild 36 low-quality PPTs with enhanced slide engine v2
- Slide engine v2: 10 slide types (title, section, content, key terms, two-column,
  three-card, stats, table, checklist, end) with consistent design system
- Each PPT now has 9-12 slides with varied layouts (was 4-5 text-only)
- EAL-friendly language: short sentences, key terms highlighted
- Key Idea callouts, Check Your Understanding checklists
- Rebuilt: G6 Sci T1 (6), T2 (6), T5 (6), G6 Math T1 (6), T2 (6), T5 (6)
- Quality: 86KB avg → 160KB avg, 1400 chars → 2500 chars avg
</commit_message>
<xml_diff>
--- a/static/ppts/G6_Math_T1_Factors_Multiples.pptx
+++ b/static/ppts/G6_Math_T1_Factors_Multiples.pptx
@@ -10,9 +10,11 @@
     <p:sldId id="258" r:id="rId4"/>
     <p:sldId id="259" r:id="rId5"/>
     <p:sldId id="260" r:id="rId6"/>
+    <p:sldId id="261" r:id="rId7"/>
+    <p:sldId id="262" r:id="rId8"/>
   </p:sldIdLst>
   <p:notesMasterIdLst>
-    <p:notesMasterId r:id="rId7"/>
+    <p:notesMasterId r:id="rId9"/>
   </p:notesMasterIdLst>
   <p:sldSz cx="9144000" cy="5143500"/>
   <p:notesSz cx="5143500" cy="9144000"/>
@@ -900,6 +902,182 @@
 </p:notes>
 </file>
 
+<file path=ppt/notesSlides/notesSlide6.xml><?xml version="1.0" encoding="utf-8"?>
+<p:notes xmlns:a="http://schemas.openxmlformats.org/drawingml/2006/main" xmlns:r="http://schemas.openxmlformats.org/officeDocument/2006/relationships" xmlns:p="http://schemas.openxmlformats.org/presentationml/2006/main">
+  <p:cSld>
+    <p:spTree>
+      <p:nvGrpSpPr>
+        <p:cNvPr id="1" name=""/>
+        <p:cNvGrpSpPr/>
+        <p:nvPr/>
+      </p:nvGrpSpPr>
+      <p:grpSpPr>
+        <a:xfrm>
+          <a:off x="0" y="0"/>
+          <a:ext cx="0" cy="0"/>
+          <a:chOff x="0" y="0"/>
+          <a:chExt cx="0" cy="0"/>
+        </a:xfrm>
+      </p:grpSpPr>
+      <p:sp>
+        <p:nvSpPr>
+          <p:cNvPr id="2" name="Slide Image Placeholder 1"/>
+          <p:cNvSpPr>
+            <a:spLocks noGrp="1" noRot="1" noChangeAspect="1"/>
+          </p:cNvSpPr>
+          <p:nvPr>
+            <p:ph type="sldImg"/>
+          </p:nvPr>
+        </p:nvSpPr>
+        <p:spPr/>
+      </p:sp>
+      <p:sp>
+        <p:nvSpPr>
+          <p:cNvPr id="3" name="Notes Placeholder 2"/>
+          <p:cNvSpPr>
+            <a:spLocks noGrp="1"/>
+          </p:cNvSpPr>
+          <p:nvPr>
+            <p:ph type="body" idx="1"/>
+          </p:nvPr>
+        </p:nvSpPr>
+        <p:spPr/>
+        <p:txBody>
+          <a:bodyPr/>
+          <a:lstStyle/>
+          <a:p>
+            <a:r>
+              <a:rPr lang="en-US" dirty="0"/>
+              <a:t/>
+            </a:r>
+            <a:endParaRPr lang="en-US" dirty="0"/>
+          </a:p>
+        </p:txBody>
+      </p:sp>
+      <p:sp>
+        <p:nvSpPr>
+          <p:cNvPr id="4" name="Slide Number Placeholder 3"/>
+          <p:cNvSpPr>
+            <a:spLocks noGrp="1"/>
+          </p:cNvSpPr>
+          <p:nvPr>
+            <p:ph type="sldNum" sz="quarter" idx="10"/>
+          </p:nvPr>
+        </p:nvSpPr>
+        <p:spPr/>
+        <p:txBody>
+          <a:bodyPr/>
+          <a:lstStyle/>
+          <a:p>
+            <a:fld id="{F7021451-1387-4CA6-816F-3879F97B5CBC}" type="slidenum">
+              <a:rPr lang="en-US"/>
+              <a:t>6</a:t>
+            </a:fld>
+            <a:endParaRPr lang="en-US"/>
+          </a:p>
+        </p:txBody>
+      </p:sp>
+    </p:spTree>
+    <p:extLst>
+      <p:ext uri="{BB962C8B-B14F-4D97-AF65-F5344CB8AC3E}">
+        <p14:creationId xmlns:p14="http://schemas.microsoft.com/office/powerpoint/2010/main" val="1024086991"/>
+      </p:ext>
+    </p:extLst>
+  </p:cSld>
+  <p:clrMapOvr>
+    <a:masterClrMapping/>
+  </p:clrMapOvr>
+</p:notes>
+</file>
+
+<file path=ppt/notesSlides/notesSlide7.xml><?xml version="1.0" encoding="utf-8"?>
+<p:notes xmlns:a="http://schemas.openxmlformats.org/drawingml/2006/main" xmlns:r="http://schemas.openxmlformats.org/officeDocument/2006/relationships" xmlns:p="http://schemas.openxmlformats.org/presentationml/2006/main">
+  <p:cSld>
+    <p:spTree>
+      <p:nvGrpSpPr>
+        <p:cNvPr id="1" name=""/>
+        <p:cNvGrpSpPr/>
+        <p:nvPr/>
+      </p:nvGrpSpPr>
+      <p:grpSpPr>
+        <a:xfrm>
+          <a:off x="0" y="0"/>
+          <a:ext cx="0" cy="0"/>
+          <a:chOff x="0" y="0"/>
+          <a:chExt cx="0" cy="0"/>
+        </a:xfrm>
+      </p:grpSpPr>
+      <p:sp>
+        <p:nvSpPr>
+          <p:cNvPr id="2" name="Slide Image Placeholder 1"/>
+          <p:cNvSpPr>
+            <a:spLocks noGrp="1" noRot="1" noChangeAspect="1"/>
+          </p:cNvSpPr>
+          <p:nvPr>
+            <p:ph type="sldImg"/>
+          </p:nvPr>
+        </p:nvSpPr>
+        <p:spPr/>
+      </p:sp>
+      <p:sp>
+        <p:nvSpPr>
+          <p:cNvPr id="3" name="Notes Placeholder 2"/>
+          <p:cNvSpPr>
+            <a:spLocks noGrp="1"/>
+          </p:cNvSpPr>
+          <p:nvPr>
+            <p:ph type="body" idx="1"/>
+          </p:nvPr>
+        </p:nvSpPr>
+        <p:spPr/>
+        <p:txBody>
+          <a:bodyPr/>
+          <a:lstStyle/>
+          <a:p>
+            <a:r>
+              <a:rPr lang="en-US" dirty="0"/>
+              <a:t/>
+            </a:r>
+            <a:endParaRPr lang="en-US" dirty="0"/>
+          </a:p>
+        </p:txBody>
+      </p:sp>
+      <p:sp>
+        <p:nvSpPr>
+          <p:cNvPr id="4" name="Slide Number Placeholder 3"/>
+          <p:cNvSpPr>
+            <a:spLocks noGrp="1"/>
+          </p:cNvSpPr>
+          <p:nvPr>
+            <p:ph type="sldNum" sz="quarter" idx="10"/>
+          </p:nvPr>
+        </p:nvSpPr>
+        <p:spPr/>
+        <p:txBody>
+          <a:bodyPr/>
+          <a:lstStyle/>
+          <a:p>
+            <a:fld id="{F7021451-1387-4CA6-816F-3879F97B5CBC}" type="slidenum">
+              <a:rPr lang="en-US"/>
+              <a:t>7</a:t>
+            </a:fld>
+            <a:endParaRPr lang="en-US"/>
+          </a:p>
+        </p:txBody>
+      </p:sp>
+    </p:spTree>
+    <p:extLst>
+      <p:ext uri="{BB962C8B-B14F-4D97-AF65-F5344CB8AC3E}">
+        <p14:creationId xmlns:p14="http://schemas.microsoft.com/office/powerpoint/2010/main" val="1024086991"/>
+      </p:ext>
+    </p:extLst>
+  </p:cSld>
+  <p:clrMapOvr>
+    <a:masterClrMapping/>
+  </p:clrMapOvr>
+</p:notes>
+</file>
+
 <file path=ppt/slideLayouts/slideLayout1.xml><?xml version="1.0" encoding="utf-8"?>
 <p:sldLayout xmlns:a="http://schemas.openxmlformats.org/drawingml/2006/main" xmlns:r="http://schemas.openxmlformats.org/officeDocument/2006/relationships" xmlns:p="http://schemas.openxmlformats.org/presentationml/2006/main" preserve="1">
   <p:cSld name="DEFAULT">
@@ -1210,13 +1388,6 @@
 <file path=ppt/slides/slide1.xml><?xml version="1.0" encoding="utf-8"?>
 <p:sld xmlns:a="http://schemas.openxmlformats.org/drawingml/2006/main" xmlns:r="http://schemas.openxmlformats.org/officeDocument/2006/relationships" xmlns:p="http://schemas.openxmlformats.org/presentationml/2006/main">
   <p:cSld name="Slide 1">
-    <p:bg>
-      <p:bgPr>
-        <a:solidFill>
-          <a:srgbClr val="1B2A4A"/>
-        </a:solidFill>
-      </p:bgPr>
-    </p:bg>
     <p:spTree>
       <p:nvGrpSpPr>
         <p:cNvPr id="1" name=""/>
@@ -1240,7 +1411,27 @@
         <p:spPr>
           <a:xfrm>
             <a:off x="0" y="0"/>
-            <a:ext cx="109728" cy="5143500"/>
+            <a:ext cx="9144000" cy="5143500"/>
+          </a:xfrm>
+          <a:prstGeom prst="rect">
+            <a:avLst/>
+          </a:prstGeom>
+          <a:solidFill>
+            <a:srgbClr val="1B2A4A"/>
+          </a:solidFill>
+          <a:ln/>
+        </p:spPr>
+      </p:sp>
+      <p:sp>
+        <p:nvSpPr>
+          <p:cNvPr id="3" name="Shape 1"/>
+          <p:cNvSpPr/>
+          <p:nvPr/>
+        </p:nvSpPr>
+        <p:spPr>
+          <a:xfrm>
+            <a:off x="0" y="4777740"/>
+            <a:ext cx="9144000" cy="365760"/>
           </a:xfrm>
           <a:prstGeom prst="rect">
             <a:avLst/>
@@ -1253,14 +1444,36 @@
       </p:sp>
       <p:sp>
         <p:nvSpPr>
-          <p:cNvPr id="3" name="Text 1"/>
-          <p:cNvSpPr/>
-          <p:nvPr/>
-        </p:nvSpPr>
-        <p:spPr>
-          <a:xfrm>
-            <a:off x="731520" y="1097280"/>
-            <a:ext cx="7772400" cy="1371600"/>
+          <p:cNvPr id="4" name="Shape 2"/>
+          <p:cNvSpPr/>
+          <p:nvPr/>
+        </p:nvSpPr>
+        <p:spPr>
+          <a:xfrm>
+            <a:off x="6858000" y="-1371600"/>
+            <a:ext cx="4572000" cy="4572000"/>
+          </a:xfrm>
+          <a:prstGeom prst="ellipse">
+            <a:avLst/>
+          </a:prstGeom>
+          <a:solidFill>
+            <a:srgbClr val="2A9D8F">
+              <a:alpha val="12000"/>
+            </a:srgbClr>
+          </a:solidFill>
+          <a:ln/>
+        </p:spPr>
+      </p:sp>
+      <p:sp>
+        <p:nvSpPr>
+          <p:cNvPr id="5" name="Text 3"/>
+          <p:cNvSpPr/>
+          <p:nvPr/>
+        </p:nvSpPr>
+        <p:spPr>
+          <a:xfrm>
+            <a:off x="731520" y="914400"/>
+            <a:ext cx="7680960" cy="457200"/>
           </a:xfrm>
           <a:prstGeom prst="rect">
             <a:avLst/>
@@ -1276,7 +1489,46 @@
               <a:buNone/>
             </a:pPr>
             <a:r>
-              <a:rPr lang="en-US" sz="4000" b="1" dirty="0">
+              <a:rPr lang="en-US" sz="1300" b="1" spc="500" kern="0" dirty="0">
+                <a:solidFill>
+                  <a:srgbClr val="2A9D8F"/>
+                </a:solidFill>
+                <a:latin typeface="Calibri" pitchFamily="34" charset="0"/>
+                <a:ea typeface="Calibri" pitchFamily="34" charset="-122"/>
+                <a:cs typeface="Calibri" pitchFamily="34" charset="-120"/>
+              </a:rPr>
+              <a:t>GRADE 6 MATHEMATICS</a:t>
+            </a:r>
+            <a:endParaRPr lang="en-US" sz="1300" dirty="0"/>
+          </a:p>
+        </p:txBody>
+      </p:sp>
+      <p:sp>
+        <p:nvSpPr>
+          <p:cNvPr id="6" name="Text 4"/>
+          <p:cNvSpPr/>
+          <p:nvPr/>
+        </p:nvSpPr>
+        <p:spPr>
+          <a:xfrm>
+            <a:off x="731520" y="1463040"/>
+            <a:ext cx="6858000" cy="1645920"/>
+          </a:xfrm>
+          <a:prstGeom prst="rect">
+            <a:avLst/>
+          </a:prstGeom>
+          <a:noFill/>
+          <a:ln/>
+        </p:spPr>
+        <p:txBody>
+          <a:bodyPr wrap="square" rtlCol="0" anchor="t"/>
+          <a:lstStyle/>
+          <a:p>
+            <a:pPr indent="0" marL="0">
+              <a:buNone/>
+            </a:pPr>
+            <a:r>
+              <a:rPr lang="en-US" sz="3800" b="1" dirty="0">
                 <a:solidFill>
                   <a:srgbClr val="FFFFFF"/>
                 </a:solidFill>
@@ -1284,46 +1536,63 @@
                 <a:ea typeface="Georgia" pitchFamily="34" charset="-122"/>
                 <a:cs typeface="Georgia" pitchFamily="34" charset="-120"/>
               </a:rPr>
-              <a:t>Factors, Multiples &amp; Primes</a:t>
-            </a:r>
-            <a:endParaRPr lang="en-US" sz="4000" dirty="0"/>
-          </a:p>
-        </p:txBody>
-      </p:sp>
-      <p:sp>
-        <p:nvSpPr>
-          <p:cNvPr id="4" name="Text 2"/>
-          <p:cNvSpPr/>
-          <p:nvPr/>
-        </p:nvSpPr>
-        <p:spPr>
-          <a:xfrm>
-            <a:off x="731520" y="2560320"/>
-            <a:ext cx="7772400" cy="548640"/>
-          </a:xfrm>
-          <a:prstGeom prst="rect">
-            <a:avLst/>
-          </a:prstGeom>
-          <a:noFill/>
-          <a:ln/>
-        </p:spPr>
-        <p:txBody>
-          <a:bodyPr wrap="square" rtlCol="0" anchor="ctr"/>
-          <a:lstStyle/>
+              <a:t>Factors, Multiples</a:t>
+            </a:r>
+            <a:endParaRPr lang="en-US" sz="3800" dirty="0"/>
+          </a:p>
           <a:p>
             <a:pPr indent="0" marL="0">
               <a:buNone/>
             </a:pPr>
             <a:r>
-              <a:rPr lang="en-US" sz="1600" dirty="0">
-                <a:solidFill>
-                  <a:srgbClr val="E9C46A"/>
+              <a:rPr lang="en-US" sz="3800" b="1" dirty="0">
+                <a:solidFill>
+                  <a:srgbClr val="FFFFFF"/>
+                </a:solidFill>
+                <a:latin typeface="Georgia" pitchFamily="34" charset="0"/>
+                <a:ea typeface="Georgia" pitchFamily="34" charset="-122"/>
+                <a:cs typeface="Georgia" pitchFamily="34" charset="-120"/>
+              </a:rPr>
+              <a:t>&amp; Primes</a:t>
+            </a:r>
+            <a:endParaRPr lang="en-US" sz="3800" dirty="0"/>
+          </a:p>
+        </p:txBody>
+      </p:sp>
+      <p:sp>
+        <p:nvSpPr>
+          <p:cNvPr id="7" name="Text 5"/>
+          <p:cNvSpPr/>
+          <p:nvPr/>
+        </p:nvSpPr>
+        <p:spPr>
+          <a:xfrm>
+            <a:off x="731520" y="3200400"/>
+            <a:ext cx="6400800" cy="548640"/>
+          </a:xfrm>
+          <a:prstGeom prst="rect">
+            <a:avLst/>
+          </a:prstGeom>
+          <a:noFill/>
+          <a:ln/>
+        </p:spPr>
+        <p:txBody>
+          <a:bodyPr wrap="square" rtlCol="0" anchor="ctr"/>
+          <a:lstStyle/>
+          <a:p>
+            <a:pPr indent="0" marL="0">
+              <a:buNone/>
+            </a:pPr>
+            <a:r>
+              <a:rPr lang="en-US" sz="1600" i="1" dirty="0">
+                <a:solidFill>
+                  <a:srgbClr val="9B9690"/>
                 </a:solidFill>
                 <a:latin typeface="Calibri" pitchFamily="34" charset="0"/>
                 <a:ea typeface="Calibri" pitchFamily="34" charset="-122"/>
                 <a:cs typeface="Calibri" pitchFamily="34" charset="-120"/>
               </a:rPr>
-              <a:t>Grade 6 Mathematics · Mr Zocchi</a:t>
+              <a:t>The building blocks of numbers</a:t>
             </a:r>
             <a:endParaRPr lang="en-US" sz="1600" dirty="0"/>
           </a:p>
@@ -1331,36 +1600,14 @@
       </p:sp>
       <p:sp>
         <p:nvSpPr>
-          <p:cNvPr id="5" name="Shape 3"/>
-          <p:cNvSpPr/>
-          <p:nvPr/>
-        </p:nvSpPr>
-        <p:spPr>
-          <a:xfrm>
-            <a:off x="731520" y="3474720"/>
-            <a:ext cx="2011680" cy="411480"/>
-          </a:xfrm>
-          <a:prstGeom prst="roundRect">
-            <a:avLst>
-              <a:gd name="adj" fmla="val 17778"/>
-            </a:avLst>
-          </a:prstGeom>
-          <a:solidFill>
-            <a:srgbClr val="2A9D8F"/>
-          </a:solidFill>
-          <a:ln/>
-        </p:spPr>
-      </p:sp>
-      <p:sp>
-        <p:nvSpPr>
-          <p:cNvPr id="6" name="Text 4"/>
-          <p:cNvSpPr/>
-          <p:nvPr/>
-        </p:nvSpPr>
-        <p:spPr>
-          <a:xfrm>
-            <a:off x="731520" y="3474720"/>
-            <a:ext cx="2011680" cy="411480"/>
+          <p:cNvPr id="8" name="Text 6"/>
+          <p:cNvSpPr/>
+          <p:nvPr/>
+        </p:nvSpPr>
+        <p:spPr>
+          <a:xfrm>
+            <a:off x="731520" y="4297680"/>
+            <a:ext cx="2743200" cy="365760"/>
           </a:xfrm>
           <a:prstGeom prst="rect">
             <a:avLst/>
@@ -1372,21 +1619,21 @@
           <a:bodyPr wrap="square" rtlCol="0" anchor="ctr"/>
           <a:lstStyle/>
           <a:p>
-            <a:pPr algn="ctr" indent="0" marL="0">
+            <a:pPr indent="0" marL="0">
               <a:buNone/>
             </a:pPr>
             <a:r>
-              <a:rPr lang="en-US" sz="1200" b="1" dirty="0">
-                <a:solidFill>
-                  <a:srgbClr val="FFFFFF"/>
+              <a:rPr lang="en-US" sz="1100" dirty="0">
+                <a:solidFill>
+                  <a:srgbClr val="9B9690"/>
                 </a:solidFill>
                 <a:latin typeface="Calibri" pitchFamily="34" charset="0"/>
                 <a:ea typeface="Calibri" pitchFamily="34" charset="-122"/>
                 <a:cs typeface="Calibri" pitchFamily="34" charset="-120"/>
               </a:rPr>
-              <a:t>Term 1 · Number Sense</a:t>
-            </a:r>
-            <a:endParaRPr lang="en-US" sz="1200" dirty="0"/>
+              <a:t>mrzocchi.com</a:t>
+            </a:r>
+            <a:endParaRPr lang="en-US" sz="1100" dirty="0"/>
           </a:p>
         </p:txBody>
       </p:sp>
@@ -1431,7 +1678,47 @@
         <p:spPr>
           <a:xfrm>
             <a:off x="0" y="0"/>
-            <a:ext cx="9144000" cy="54864"/>
+            <a:ext cx="9144000" cy="822960"/>
+          </a:xfrm>
+          <a:prstGeom prst="rect">
+            <a:avLst/>
+          </a:prstGeom>
+          <a:solidFill>
+            <a:srgbClr val="FFFFFF"/>
+          </a:solidFill>
+          <a:ln/>
+        </p:spPr>
+      </p:sp>
+      <p:sp>
+        <p:nvSpPr>
+          <p:cNvPr id="3" name="Shape 1"/>
+          <p:cNvSpPr/>
+          <p:nvPr/>
+        </p:nvSpPr>
+        <p:spPr>
+          <a:xfrm>
+            <a:off x="0" y="804672"/>
+            <a:ext cx="9144000" cy="27432"/>
+          </a:xfrm>
+          <a:prstGeom prst="rect">
+            <a:avLst/>
+          </a:prstGeom>
+          <a:solidFill>
+            <a:srgbClr val="E5E2DC"/>
+          </a:solidFill>
+          <a:ln/>
+        </p:spPr>
+      </p:sp>
+      <p:sp>
+        <p:nvSpPr>
+          <p:cNvPr id="4" name="Shape 2"/>
+          <p:cNvSpPr/>
+          <p:nvPr/>
+        </p:nvSpPr>
+        <p:spPr>
+          <a:xfrm>
+            <a:off x="548640" y="201168"/>
+            <a:ext cx="54864" cy="420624"/>
           </a:xfrm>
           <a:prstGeom prst="rect">
             <a:avLst/>
@@ -1444,14 +1731,14 @@
       </p:sp>
       <p:sp>
         <p:nvSpPr>
-          <p:cNvPr id="3" name="Text 1"/>
-          <p:cNvSpPr/>
-          <p:nvPr/>
-        </p:nvSpPr>
-        <p:spPr>
-          <a:xfrm>
-            <a:off x="7772400" y="4709160"/>
-            <a:ext cx="1097280" cy="320040"/>
+          <p:cNvPr id="5" name="Text 3"/>
+          <p:cNvSpPr/>
+          <p:nvPr/>
+        </p:nvSpPr>
+        <p:spPr>
+          <a:xfrm>
+            <a:off x="777240" y="137160"/>
+            <a:ext cx="7772400" cy="548640"/>
           </a:xfrm>
           <a:prstGeom prst="rect">
             <a:avLst/>
@@ -1460,37 +1747,37 @@
           <a:ln/>
         </p:spPr>
         <p:txBody>
-          <a:bodyPr wrap="square" rtlCol="0" anchor="ctr"/>
-          <a:lstStyle/>
-          <a:p>
-            <a:pPr algn="r" indent="0" marL="0">
+          <a:bodyPr wrap="square" lIns="0" tIns="0" rIns="0" bIns="0" rtlCol="0" anchor="ctr"/>
+          <a:lstStyle/>
+          <a:p>
+            <a:pPr indent="0" marL="0">
               <a:buNone/>
             </a:pPr>
             <a:r>
-              <a:rPr lang="en-US" sz="900" dirty="0">
-                <a:solidFill>
-                  <a:srgbClr val="6B6660"/>
-                </a:solidFill>
-                <a:latin typeface="Calibri" pitchFamily="34" charset="0"/>
-                <a:ea typeface="Calibri" pitchFamily="34" charset="-122"/>
-                <a:cs typeface="Calibri" pitchFamily="34" charset="-120"/>
-              </a:rPr>
-              <a:t>2 / 5</a:t>
-            </a:r>
-            <a:endParaRPr lang="en-US" sz="900" dirty="0"/>
-          </a:p>
-        </p:txBody>
-      </p:sp>
-      <p:sp>
-        <p:nvSpPr>
-          <p:cNvPr id="4" name="Shape 2"/>
-          <p:cNvSpPr/>
-          <p:nvPr/>
-        </p:nvSpPr>
-        <p:spPr>
-          <a:xfrm>
-            <a:off x="1371600" y="914400"/>
-            <a:ext cx="6400800" cy="3200400"/>
+              <a:rPr lang="en-US" sz="2000" b="1" dirty="0">
+                <a:solidFill>
+                  <a:srgbClr val="1B2A4A"/>
+                </a:solidFill>
+                <a:latin typeface="Georgia" pitchFamily="34" charset="0"/>
+                <a:ea typeface="Georgia" pitchFamily="34" charset="-122"/>
+                <a:cs typeface="Georgia" pitchFamily="34" charset="-120"/>
+              </a:rPr>
+              <a:t>Key Vocabulary</a:t>
+            </a:r>
+            <a:endParaRPr lang="en-US" sz="2000" dirty="0"/>
+          </a:p>
+        </p:txBody>
+      </p:sp>
+      <p:sp>
+        <p:nvSpPr>
+          <p:cNvPr id="6" name="Shape 4"/>
+          <p:cNvSpPr/>
+          <p:nvPr/>
+        </p:nvSpPr>
+        <p:spPr>
+          <a:xfrm>
+            <a:off x="731520" y="1051560"/>
+            <a:ext cx="3657600" cy="658368"/>
           </a:xfrm>
           <a:prstGeom prst="rect">
             <a:avLst/>
@@ -1498,12 +1785,7 @@
           <a:solidFill>
             <a:srgbClr val="FFFFFF"/>
           </a:solidFill>
-          <a:ln w="12700">
-            <a:solidFill>
-              <a:srgbClr val="E5E2DC"/>
-            </a:solidFill>
-            <a:prstDash val="solid"/>
-          </a:ln>
+          <a:ln/>
           <a:effectLst>
             <a:outerShdw sx="100000" sy="100000" kx="0" ky="0" algn="bl" rotWithShape="0" blurRad="50800" dist="25400" dir="8100000">
               <a:srgbClr val="000000">
@@ -1515,14 +1797,14 @@
       </p:sp>
       <p:sp>
         <p:nvSpPr>
-          <p:cNvPr id="5" name="Shape 3"/>
-          <p:cNvSpPr/>
-          <p:nvPr/>
-        </p:nvSpPr>
-        <p:spPr>
-          <a:xfrm>
-            <a:off x="1371600" y="914400"/>
-            <a:ext cx="91440" cy="3200400"/>
+          <p:cNvPr id="7" name="Shape 5"/>
+          <p:cNvSpPr/>
+          <p:nvPr/>
+        </p:nvSpPr>
+        <p:spPr>
+          <a:xfrm>
+            <a:off x="731520" y="1051560"/>
+            <a:ext cx="54864" cy="658368"/>
           </a:xfrm>
           <a:prstGeom prst="rect">
             <a:avLst/>
@@ -1535,14 +1817,14 @@
       </p:sp>
       <p:sp>
         <p:nvSpPr>
-          <p:cNvPr id="6" name="Text 4"/>
-          <p:cNvSpPr/>
-          <p:nvPr/>
-        </p:nvSpPr>
-        <p:spPr>
-          <a:xfrm>
-            <a:off x="1828800" y="1097280"/>
-            <a:ext cx="5669280" cy="640080"/>
+          <p:cNvPr id="8" name="Text 6"/>
+          <p:cNvSpPr/>
+          <p:nvPr/>
+        </p:nvSpPr>
+        <p:spPr>
+          <a:xfrm>
+            <a:off x="914400" y="1051560"/>
+            <a:ext cx="1463040" cy="658368"/>
           </a:xfrm>
           <a:prstGeom prst="rect">
             <a:avLst/>
@@ -1551,14 +1833,14 @@
           <a:ln/>
         </p:spPr>
         <p:txBody>
-          <a:bodyPr wrap="square" rtlCol="0" anchor="ctr"/>
+          <a:bodyPr wrap="square" lIns="0" tIns="0" rIns="0" bIns="0" rtlCol="0" anchor="ctr"/>
           <a:lstStyle/>
           <a:p>
             <a:pPr indent="0" marL="0">
               <a:buNone/>
             </a:pPr>
             <a:r>
-              <a:rPr lang="en-US" sz="2400" b="1" dirty="0">
+              <a:rPr lang="en-US" sz="1300" b="1" dirty="0">
                 <a:solidFill>
                   <a:srgbClr val="1B2A4A"/>
                 </a:solidFill>
@@ -1566,22 +1848,22 @@
                 <a:ea typeface="Georgia" pitchFamily="34" charset="-122"/>
                 <a:cs typeface="Georgia" pitchFamily="34" charset="-120"/>
               </a:rPr>
-              <a:t>Building Blocks of Numbers</a:t>
-            </a:r>
-            <a:endParaRPr lang="en-US" sz="2400" dirty="0"/>
-          </a:p>
-        </p:txBody>
-      </p:sp>
-      <p:sp>
-        <p:nvSpPr>
-          <p:cNvPr id="7" name="Text 5"/>
-          <p:cNvSpPr/>
-          <p:nvPr/>
-        </p:nvSpPr>
-        <p:spPr>
-          <a:xfrm>
-            <a:off x="1828800" y="1828800"/>
-            <a:ext cx="5669280" cy="2011680"/>
+              <a:t>Factor</a:t>
+            </a:r>
+            <a:endParaRPr lang="en-US" sz="1300" dirty="0"/>
+          </a:p>
+        </p:txBody>
+      </p:sp>
+      <p:sp>
+        <p:nvSpPr>
+          <p:cNvPr id="9" name="Text 7"/>
+          <p:cNvSpPr/>
+          <p:nvPr/>
+        </p:nvSpPr>
+        <p:spPr>
+          <a:xfrm>
+            <a:off x="2377440" y="1051560"/>
+            <a:ext cx="1920240" cy="658368"/>
           </a:xfrm>
           <a:prstGeom prst="rect">
             <a:avLst/>
@@ -1590,27 +1872,649 @@
           <a:ln/>
         </p:spPr>
         <p:txBody>
-          <a:bodyPr wrap="square" rtlCol="0" anchor="t"/>
+          <a:bodyPr wrap="square" lIns="0" tIns="0" rIns="0" bIns="0" rtlCol="0" anchor="ctr"/>
           <a:lstStyle/>
           <a:p>
             <a:pPr indent="0" marL="0">
-              <a:lnSpc>
-                <a:spcPct val="130000"/>
-              </a:lnSpc>
               <a:buNone/>
             </a:pPr>
             <a:r>
-              <a:rPr lang="en-US" sz="1500" dirty="0">
-                <a:solidFill>
-                  <a:srgbClr val="3D3A36"/>
+              <a:rPr lang="en-US" sz="1100" dirty="0">
+                <a:solidFill>
+                  <a:srgbClr val="6B6660"/>
                 </a:solidFill>
                 <a:latin typeface="Calibri" pitchFamily="34" charset="0"/>
                 <a:ea typeface="Calibri" pitchFamily="34" charset="-122"/>
                 <a:cs typeface="Calibri" pitchFamily="34" charset="-120"/>
               </a:rPr>
-              <a:t>Factors and multiples are the fundamental relationships between numbers. Understanding them helps with simplifying fractions, finding common denominators, and solving problems. Prime numbers are the 'atoms' of mathematics — every number can be built from them.</a:t>
-            </a:r>
-            <a:endParaRPr lang="en-US" sz="1500" dirty="0"/>
+              <a:t>A number that divides exactly into another</a:t>
+            </a:r>
+            <a:endParaRPr lang="en-US" sz="1100" dirty="0"/>
+          </a:p>
+        </p:txBody>
+      </p:sp>
+      <p:sp>
+        <p:nvSpPr>
+          <p:cNvPr id="10" name="Shape 8"/>
+          <p:cNvSpPr/>
+          <p:nvPr/>
+        </p:nvSpPr>
+        <p:spPr>
+          <a:xfrm>
+            <a:off x="4754880" y="1051560"/>
+            <a:ext cx="3657600" cy="658368"/>
+          </a:xfrm>
+          <a:prstGeom prst="rect">
+            <a:avLst/>
+          </a:prstGeom>
+          <a:solidFill>
+            <a:srgbClr val="FFFFFF"/>
+          </a:solidFill>
+          <a:ln/>
+          <a:effectLst>
+            <a:outerShdw sx="100000" sy="100000" kx="0" ky="0" algn="bl" rotWithShape="0" blurRad="50800" dist="25400" dir="8100000">
+              <a:srgbClr val="000000">
+                <a:alpha val="10000"/>
+              </a:srgbClr>
+            </a:outerShdw>
+          </a:effectLst>
+        </p:spPr>
+      </p:sp>
+      <p:sp>
+        <p:nvSpPr>
+          <p:cNvPr id="11" name="Shape 9"/>
+          <p:cNvSpPr/>
+          <p:nvPr/>
+        </p:nvSpPr>
+        <p:spPr>
+          <a:xfrm>
+            <a:off x="4754880" y="1051560"/>
+            <a:ext cx="54864" cy="658368"/>
+          </a:xfrm>
+          <a:prstGeom prst="rect">
+            <a:avLst/>
+          </a:prstGeom>
+          <a:solidFill>
+            <a:srgbClr val="2A9D8F"/>
+          </a:solidFill>
+          <a:ln/>
+        </p:spPr>
+      </p:sp>
+      <p:sp>
+        <p:nvSpPr>
+          <p:cNvPr id="12" name="Text 10"/>
+          <p:cNvSpPr/>
+          <p:nvPr/>
+        </p:nvSpPr>
+        <p:spPr>
+          <a:xfrm>
+            <a:off x="4937760" y="1051560"/>
+            <a:ext cx="1463040" cy="658368"/>
+          </a:xfrm>
+          <a:prstGeom prst="rect">
+            <a:avLst/>
+          </a:prstGeom>
+          <a:noFill/>
+          <a:ln/>
+        </p:spPr>
+        <p:txBody>
+          <a:bodyPr wrap="square" lIns="0" tIns="0" rIns="0" bIns="0" rtlCol="0" anchor="ctr"/>
+          <a:lstStyle/>
+          <a:p>
+            <a:pPr indent="0" marL="0">
+              <a:buNone/>
+            </a:pPr>
+            <a:r>
+              <a:rPr lang="en-US" sz="1300" b="1" dirty="0">
+                <a:solidFill>
+                  <a:srgbClr val="1B2A4A"/>
+                </a:solidFill>
+                <a:latin typeface="Georgia" pitchFamily="34" charset="0"/>
+                <a:ea typeface="Georgia" pitchFamily="34" charset="-122"/>
+                <a:cs typeface="Georgia" pitchFamily="34" charset="-120"/>
+              </a:rPr>
+              <a:t>Multiple</a:t>
+            </a:r>
+            <a:endParaRPr lang="en-US" sz="1300" dirty="0"/>
+          </a:p>
+        </p:txBody>
+      </p:sp>
+      <p:sp>
+        <p:nvSpPr>
+          <p:cNvPr id="13" name="Text 11"/>
+          <p:cNvSpPr/>
+          <p:nvPr/>
+        </p:nvSpPr>
+        <p:spPr>
+          <a:xfrm>
+            <a:off x="6400800" y="1051560"/>
+            <a:ext cx="1920240" cy="658368"/>
+          </a:xfrm>
+          <a:prstGeom prst="rect">
+            <a:avLst/>
+          </a:prstGeom>
+          <a:noFill/>
+          <a:ln/>
+        </p:spPr>
+        <p:txBody>
+          <a:bodyPr wrap="square" lIns="0" tIns="0" rIns="0" bIns="0" rtlCol="0" anchor="ctr"/>
+          <a:lstStyle/>
+          <a:p>
+            <a:pPr indent="0" marL="0">
+              <a:buNone/>
+            </a:pPr>
+            <a:r>
+              <a:rPr lang="en-US" sz="1100" dirty="0">
+                <a:solidFill>
+                  <a:srgbClr val="6B6660"/>
+                </a:solidFill>
+                <a:latin typeface="Calibri" pitchFamily="34" charset="0"/>
+                <a:ea typeface="Calibri" pitchFamily="34" charset="-122"/>
+                <a:cs typeface="Calibri" pitchFamily="34" charset="-120"/>
+              </a:rPr>
+              <a:t>The result of multiplying a number</a:t>
+            </a:r>
+            <a:endParaRPr lang="en-US" sz="1100" dirty="0"/>
+          </a:p>
+        </p:txBody>
+      </p:sp>
+      <p:sp>
+        <p:nvSpPr>
+          <p:cNvPr id="14" name="Shape 12"/>
+          <p:cNvSpPr/>
+          <p:nvPr/>
+        </p:nvSpPr>
+        <p:spPr>
+          <a:xfrm>
+            <a:off x="731520" y="1819656"/>
+            <a:ext cx="3657600" cy="658368"/>
+          </a:xfrm>
+          <a:prstGeom prst="rect">
+            <a:avLst/>
+          </a:prstGeom>
+          <a:solidFill>
+            <a:srgbClr val="FFFFFF"/>
+          </a:solidFill>
+          <a:ln/>
+          <a:effectLst>
+            <a:outerShdw sx="100000" sy="100000" kx="0" ky="0" algn="bl" rotWithShape="0" blurRad="50800" dist="25400" dir="8100000">
+              <a:srgbClr val="000000">
+                <a:alpha val="10000"/>
+              </a:srgbClr>
+            </a:outerShdw>
+          </a:effectLst>
+        </p:spPr>
+      </p:sp>
+      <p:sp>
+        <p:nvSpPr>
+          <p:cNvPr id="15" name="Shape 13"/>
+          <p:cNvSpPr/>
+          <p:nvPr/>
+        </p:nvSpPr>
+        <p:spPr>
+          <a:xfrm>
+            <a:off x="731520" y="1819656"/>
+            <a:ext cx="54864" cy="658368"/>
+          </a:xfrm>
+          <a:prstGeom prst="rect">
+            <a:avLst/>
+          </a:prstGeom>
+          <a:solidFill>
+            <a:srgbClr val="2A9D8F"/>
+          </a:solidFill>
+          <a:ln/>
+        </p:spPr>
+      </p:sp>
+      <p:sp>
+        <p:nvSpPr>
+          <p:cNvPr id="16" name="Text 14"/>
+          <p:cNvSpPr/>
+          <p:nvPr/>
+        </p:nvSpPr>
+        <p:spPr>
+          <a:xfrm>
+            <a:off x="914400" y="1819656"/>
+            <a:ext cx="1463040" cy="658368"/>
+          </a:xfrm>
+          <a:prstGeom prst="rect">
+            <a:avLst/>
+          </a:prstGeom>
+          <a:noFill/>
+          <a:ln/>
+        </p:spPr>
+        <p:txBody>
+          <a:bodyPr wrap="square" lIns="0" tIns="0" rIns="0" bIns="0" rtlCol="0" anchor="ctr"/>
+          <a:lstStyle/>
+          <a:p>
+            <a:pPr indent="0" marL="0">
+              <a:buNone/>
+            </a:pPr>
+            <a:r>
+              <a:rPr lang="en-US" sz="1300" b="1" dirty="0">
+                <a:solidFill>
+                  <a:srgbClr val="1B2A4A"/>
+                </a:solidFill>
+                <a:latin typeface="Georgia" pitchFamily="34" charset="0"/>
+                <a:ea typeface="Georgia" pitchFamily="34" charset="-122"/>
+                <a:cs typeface="Georgia" pitchFamily="34" charset="-120"/>
+              </a:rPr>
+              <a:t>Prime</a:t>
+            </a:r>
+            <a:endParaRPr lang="en-US" sz="1300" dirty="0"/>
+          </a:p>
+        </p:txBody>
+      </p:sp>
+      <p:sp>
+        <p:nvSpPr>
+          <p:cNvPr id="17" name="Text 15"/>
+          <p:cNvSpPr/>
+          <p:nvPr/>
+        </p:nvSpPr>
+        <p:spPr>
+          <a:xfrm>
+            <a:off x="2377440" y="1819656"/>
+            <a:ext cx="1920240" cy="658368"/>
+          </a:xfrm>
+          <a:prstGeom prst="rect">
+            <a:avLst/>
+          </a:prstGeom>
+          <a:noFill/>
+          <a:ln/>
+        </p:spPr>
+        <p:txBody>
+          <a:bodyPr wrap="square" lIns="0" tIns="0" rIns="0" bIns="0" rtlCol="0" anchor="ctr"/>
+          <a:lstStyle/>
+          <a:p>
+            <a:pPr indent="0" marL="0">
+              <a:buNone/>
+            </a:pPr>
+            <a:r>
+              <a:rPr lang="en-US" sz="1100" dirty="0">
+                <a:solidFill>
+                  <a:srgbClr val="6B6660"/>
+                </a:solidFill>
+                <a:latin typeface="Calibri" pitchFamily="34" charset="0"/>
+                <a:ea typeface="Calibri" pitchFamily="34" charset="-122"/>
+                <a:cs typeface="Calibri" pitchFamily="34" charset="-120"/>
+              </a:rPr>
+              <a:t>A number with exactly 2 factors (1 and itself)</a:t>
+            </a:r>
+            <a:endParaRPr lang="en-US" sz="1100" dirty="0"/>
+          </a:p>
+        </p:txBody>
+      </p:sp>
+      <p:sp>
+        <p:nvSpPr>
+          <p:cNvPr id="18" name="Shape 16"/>
+          <p:cNvSpPr/>
+          <p:nvPr/>
+        </p:nvSpPr>
+        <p:spPr>
+          <a:xfrm>
+            <a:off x="4754880" y="1819656"/>
+            <a:ext cx="3657600" cy="658368"/>
+          </a:xfrm>
+          <a:prstGeom prst="rect">
+            <a:avLst/>
+          </a:prstGeom>
+          <a:solidFill>
+            <a:srgbClr val="FFFFFF"/>
+          </a:solidFill>
+          <a:ln/>
+          <a:effectLst>
+            <a:outerShdw sx="100000" sy="100000" kx="0" ky="0" algn="bl" rotWithShape="0" blurRad="50800" dist="25400" dir="8100000">
+              <a:srgbClr val="000000">
+                <a:alpha val="10000"/>
+              </a:srgbClr>
+            </a:outerShdw>
+          </a:effectLst>
+        </p:spPr>
+      </p:sp>
+      <p:sp>
+        <p:nvSpPr>
+          <p:cNvPr id="19" name="Shape 17"/>
+          <p:cNvSpPr/>
+          <p:nvPr/>
+        </p:nvSpPr>
+        <p:spPr>
+          <a:xfrm>
+            <a:off x="4754880" y="1819656"/>
+            <a:ext cx="54864" cy="658368"/>
+          </a:xfrm>
+          <a:prstGeom prst="rect">
+            <a:avLst/>
+          </a:prstGeom>
+          <a:solidFill>
+            <a:srgbClr val="2A9D8F"/>
+          </a:solidFill>
+          <a:ln/>
+        </p:spPr>
+      </p:sp>
+      <p:sp>
+        <p:nvSpPr>
+          <p:cNvPr id="20" name="Text 18"/>
+          <p:cNvSpPr/>
+          <p:nvPr/>
+        </p:nvSpPr>
+        <p:spPr>
+          <a:xfrm>
+            <a:off x="4937760" y="1819656"/>
+            <a:ext cx="1463040" cy="658368"/>
+          </a:xfrm>
+          <a:prstGeom prst="rect">
+            <a:avLst/>
+          </a:prstGeom>
+          <a:noFill/>
+          <a:ln/>
+        </p:spPr>
+        <p:txBody>
+          <a:bodyPr wrap="square" lIns="0" tIns="0" rIns="0" bIns="0" rtlCol="0" anchor="ctr"/>
+          <a:lstStyle/>
+          <a:p>
+            <a:pPr indent="0" marL="0">
+              <a:buNone/>
+            </a:pPr>
+            <a:r>
+              <a:rPr lang="en-US" sz="1300" b="1" dirty="0">
+                <a:solidFill>
+                  <a:srgbClr val="1B2A4A"/>
+                </a:solidFill>
+                <a:latin typeface="Georgia" pitchFamily="34" charset="0"/>
+                <a:ea typeface="Georgia" pitchFamily="34" charset="-122"/>
+                <a:cs typeface="Georgia" pitchFamily="34" charset="-120"/>
+              </a:rPr>
+              <a:t>Composite</a:t>
+            </a:r>
+            <a:endParaRPr lang="en-US" sz="1300" dirty="0"/>
+          </a:p>
+        </p:txBody>
+      </p:sp>
+      <p:sp>
+        <p:nvSpPr>
+          <p:cNvPr id="21" name="Text 19"/>
+          <p:cNvSpPr/>
+          <p:nvPr/>
+        </p:nvSpPr>
+        <p:spPr>
+          <a:xfrm>
+            <a:off x="6400800" y="1819656"/>
+            <a:ext cx="1920240" cy="658368"/>
+          </a:xfrm>
+          <a:prstGeom prst="rect">
+            <a:avLst/>
+          </a:prstGeom>
+          <a:noFill/>
+          <a:ln/>
+        </p:spPr>
+        <p:txBody>
+          <a:bodyPr wrap="square" lIns="0" tIns="0" rIns="0" bIns="0" rtlCol="0" anchor="ctr"/>
+          <a:lstStyle/>
+          <a:p>
+            <a:pPr indent="0" marL="0">
+              <a:buNone/>
+            </a:pPr>
+            <a:r>
+              <a:rPr lang="en-US" sz="1100" dirty="0">
+                <a:solidFill>
+                  <a:srgbClr val="6B6660"/>
+                </a:solidFill>
+                <a:latin typeface="Calibri" pitchFamily="34" charset="0"/>
+                <a:ea typeface="Calibri" pitchFamily="34" charset="-122"/>
+                <a:cs typeface="Calibri" pitchFamily="34" charset="-120"/>
+              </a:rPr>
+              <a:t>A number with more than 2 factors</a:t>
+            </a:r>
+            <a:endParaRPr lang="en-US" sz="1100" dirty="0"/>
+          </a:p>
+        </p:txBody>
+      </p:sp>
+      <p:sp>
+        <p:nvSpPr>
+          <p:cNvPr id="22" name="Shape 20"/>
+          <p:cNvSpPr/>
+          <p:nvPr/>
+        </p:nvSpPr>
+        <p:spPr>
+          <a:xfrm>
+            <a:off x="731520" y="2587752"/>
+            <a:ext cx="3657600" cy="658368"/>
+          </a:xfrm>
+          <a:prstGeom prst="rect">
+            <a:avLst/>
+          </a:prstGeom>
+          <a:solidFill>
+            <a:srgbClr val="FFFFFF"/>
+          </a:solidFill>
+          <a:ln/>
+          <a:effectLst>
+            <a:outerShdw sx="100000" sy="100000" kx="0" ky="0" algn="bl" rotWithShape="0" blurRad="50800" dist="25400" dir="8100000">
+              <a:srgbClr val="000000">
+                <a:alpha val="10000"/>
+              </a:srgbClr>
+            </a:outerShdw>
+          </a:effectLst>
+        </p:spPr>
+      </p:sp>
+      <p:sp>
+        <p:nvSpPr>
+          <p:cNvPr id="23" name="Shape 21"/>
+          <p:cNvSpPr/>
+          <p:nvPr/>
+        </p:nvSpPr>
+        <p:spPr>
+          <a:xfrm>
+            <a:off x="731520" y="2587752"/>
+            <a:ext cx="54864" cy="658368"/>
+          </a:xfrm>
+          <a:prstGeom prst="rect">
+            <a:avLst/>
+          </a:prstGeom>
+          <a:solidFill>
+            <a:srgbClr val="2A9D8F"/>
+          </a:solidFill>
+          <a:ln/>
+        </p:spPr>
+      </p:sp>
+      <p:sp>
+        <p:nvSpPr>
+          <p:cNvPr id="24" name="Text 22"/>
+          <p:cNvSpPr/>
+          <p:nvPr/>
+        </p:nvSpPr>
+        <p:spPr>
+          <a:xfrm>
+            <a:off x="914400" y="2587752"/>
+            <a:ext cx="1463040" cy="658368"/>
+          </a:xfrm>
+          <a:prstGeom prst="rect">
+            <a:avLst/>
+          </a:prstGeom>
+          <a:noFill/>
+          <a:ln/>
+        </p:spPr>
+        <p:txBody>
+          <a:bodyPr wrap="square" lIns="0" tIns="0" rIns="0" bIns="0" rtlCol="0" anchor="ctr"/>
+          <a:lstStyle/>
+          <a:p>
+            <a:pPr indent="0" marL="0">
+              <a:buNone/>
+            </a:pPr>
+            <a:r>
+              <a:rPr lang="en-US" sz="1300" b="1" dirty="0">
+                <a:solidFill>
+                  <a:srgbClr val="1B2A4A"/>
+                </a:solidFill>
+                <a:latin typeface="Georgia" pitchFamily="34" charset="0"/>
+                <a:ea typeface="Georgia" pitchFamily="34" charset="-122"/>
+                <a:cs typeface="Georgia" pitchFamily="34" charset="-120"/>
+              </a:rPr>
+              <a:t>HCF</a:t>
+            </a:r>
+            <a:endParaRPr lang="en-US" sz="1300" dirty="0"/>
+          </a:p>
+        </p:txBody>
+      </p:sp>
+      <p:sp>
+        <p:nvSpPr>
+          <p:cNvPr id="25" name="Text 23"/>
+          <p:cNvSpPr/>
+          <p:nvPr/>
+        </p:nvSpPr>
+        <p:spPr>
+          <a:xfrm>
+            <a:off x="2377440" y="2587752"/>
+            <a:ext cx="1920240" cy="658368"/>
+          </a:xfrm>
+          <a:prstGeom prst="rect">
+            <a:avLst/>
+          </a:prstGeom>
+          <a:noFill/>
+          <a:ln/>
+        </p:spPr>
+        <p:txBody>
+          <a:bodyPr wrap="square" lIns="0" tIns="0" rIns="0" bIns="0" rtlCol="0" anchor="ctr"/>
+          <a:lstStyle/>
+          <a:p>
+            <a:pPr indent="0" marL="0">
+              <a:buNone/>
+            </a:pPr>
+            <a:r>
+              <a:rPr lang="en-US" sz="1100" dirty="0">
+                <a:solidFill>
+                  <a:srgbClr val="6B6660"/>
+                </a:solidFill>
+                <a:latin typeface="Calibri" pitchFamily="34" charset="0"/>
+                <a:ea typeface="Calibri" pitchFamily="34" charset="-122"/>
+                <a:cs typeface="Calibri" pitchFamily="34" charset="-120"/>
+              </a:rPr>
+              <a:t>Highest Common Factor</a:t>
+            </a:r>
+            <a:endParaRPr lang="en-US" sz="1100" dirty="0"/>
+          </a:p>
+        </p:txBody>
+      </p:sp>
+      <p:sp>
+        <p:nvSpPr>
+          <p:cNvPr id="26" name="Shape 24"/>
+          <p:cNvSpPr/>
+          <p:nvPr/>
+        </p:nvSpPr>
+        <p:spPr>
+          <a:xfrm>
+            <a:off x="4754880" y="2587752"/>
+            <a:ext cx="3657600" cy="658368"/>
+          </a:xfrm>
+          <a:prstGeom prst="rect">
+            <a:avLst/>
+          </a:prstGeom>
+          <a:solidFill>
+            <a:srgbClr val="FFFFFF"/>
+          </a:solidFill>
+          <a:ln/>
+          <a:effectLst>
+            <a:outerShdw sx="100000" sy="100000" kx="0" ky="0" algn="bl" rotWithShape="0" blurRad="50800" dist="25400" dir="8100000">
+              <a:srgbClr val="000000">
+                <a:alpha val="10000"/>
+              </a:srgbClr>
+            </a:outerShdw>
+          </a:effectLst>
+        </p:spPr>
+      </p:sp>
+      <p:sp>
+        <p:nvSpPr>
+          <p:cNvPr id="27" name="Shape 25"/>
+          <p:cNvSpPr/>
+          <p:nvPr/>
+        </p:nvSpPr>
+        <p:spPr>
+          <a:xfrm>
+            <a:off x="4754880" y="2587752"/>
+            <a:ext cx="54864" cy="658368"/>
+          </a:xfrm>
+          <a:prstGeom prst="rect">
+            <a:avLst/>
+          </a:prstGeom>
+          <a:solidFill>
+            <a:srgbClr val="2A9D8F"/>
+          </a:solidFill>
+          <a:ln/>
+        </p:spPr>
+      </p:sp>
+      <p:sp>
+        <p:nvSpPr>
+          <p:cNvPr id="28" name="Text 26"/>
+          <p:cNvSpPr/>
+          <p:nvPr/>
+        </p:nvSpPr>
+        <p:spPr>
+          <a:xfrm>
+            <a:off x="4937760" y="2587752"/>
+            <a:ext cx="1463040" cy="658368"/>
+          </a:xfrm>
+          <a:prstGeom prst="rect">
+            <a:avLst/>
+          </a:prstGeom>
+          <a:noFill/>
+          <a:ln/>
+        </p:spPr>
+        <p:txBody>
+          <a:bodyPr wrap="square" lIns="0" tIns="0" rIns="0" bIns="0" rtlCol="0" anchor="ctr"/>
+          <a:lstStyle/>
+          <a:p>
+            <a:pPr indent="0" marL="0">
+              <a:buNone/>
+            </a:pPr>
+            <a:r>
+              <a:rPr lang="en-US" sz="1300" b="1" dirty="0">
+                <a:solidFill>
+                  <a:srgbClr val="1B2A4A"/>
+                </a:solidFill>
+                <a:latin typeface="Georgia" pitchFamily="34" charset="0"/>
+                <a:ea typeface="Georgia" pitchFamily="34" charset="-122"/>
+                <a:cs typeface="Georgia" pitchFamily="34" charset="-120"/>
+              </a:rPr>
+              <a:t>LCM</a:t>
+            </a:r>
+            <a:endParaRPr lang="en-US" sz="1300" dirty="0"/>
+          </a:p>
+        </p:txBody>
+      </p:sp>
+      <p:sp>
+        <p:nvSpPr>
+          <p:cNvPr id="29" name="Text 27"/>
+          <p:cNvSpPr/>
+          <p:nvPr/>
+        </p:nvSpPr>
+        <p:spPr>
+          <a:xfrm>
+            <a:off x="6400800" y="2587752"/>
+            <a:ext cx="1920240" cy="658368"/>
+          </a:xfrm>
+          <a:prstGeom prst="rect">
+            <a:avLst/>
+          </a:prstGeom>
+          <a:noFill/>
+          <a:ln/>
+        </p:spPr>
+        <p:txBody>
+          <a:bodyPr wrap="square" lIns="0" tIns="0" rIns="0" bIns="0" rtlCol="0" anchor="ctr"/>
+          <a:lstStyle/>
+          <a:p>
+            <a:pPr indent="0" marL="0">
+              <a:buNone/>
+            </a:pPr>
+            <a:r>
+              <a:rPr lang="en-US" sz="1100" dirty="0">
+                <a:solidFill>
+                  <a:srgbClr val="6B6660"/>
+                </a:solidFill>
+                <a:latin typeface="Calibri" pitchFamily="34" charset="0"/>
+                <a:ea typeface="Calibri" pitchFamily="34" charset="-122"/>
+                <a:cs typeface="Calibri" pitchFamily="34" charset="-120"/>
+              </a:rPr>
+              <a:t>Lowest Common Multiple</a:t>
+            </a:r>
+            <a:endParaRPr lang="en-US" sz="1100" dirty="0"/>
           </a:p>
         </p:txBody>
       </p:sp>
@@ -1655,7 +2559,47 @@
         <p:spPr>
           <a:xfrm>
             <a:off x="0" y="0"/>
-            <a:ext cx="9144000" cy="54864"/>
+            <a:ext cx="9144000" cy="822960"/>
+          </a:xfrm>
+          <a:prstGeom prst="rect">
+            <a:avLst/>
+          </a:prstGeom>
+          <a:solidFill>
+            <a:srgbClr val="FFFFFF"/>
+          </a:solidFill>
+          <a:ln/>
+        </p:spPr>
+      </p:sp>
+      <p:sp>
+        <p:nvSpPr>
+          <p:cNvPr id="3" name="Shape 1"/>
+          <p:cNvSpPr/>
+          <p:nvPr/>
+        </p:nvSpPr>
+        <p:spPr>
+          <a:xfrm>
+            <a:off x="0" y="804672"/>
+            <a:ext cx="9144000" cy="27432"/>
+          </a:xfrm>
+          <a:prstGeom prst="rect">
+            <a:avLst/>
+          </a:prstGeom>
+          <a:solidFill>
+            <a:srgbClr val="E5E2DC"/>
+          </a:solidFill>
+          <a:ln/>
+        </p:spPr>
+      </p:sp>
+      <p:sp>
+        <p:nvSpPr>
+          <p:cNvPr id="4" name="Shape 2"/>
+          <p:cNvSpPr/>
+          <p:nvPr/>
+        </p:nvSpPr>
+        <p:spPr>
+          <a:xfrm>
+            <a:off x="548640" y="201168"/>
+            <a:ext cx="54864" cy="420624"/>
           </a:xfrm>
           <a:prstGeom prst="rect">
             <a:avLst/>
@@ -1668,14 +2612,14 @@
       </p:sp>
       <p:sp>
         <p:nvSpPr>
-          <p:cNvPr id="3" name="Text 1"/>
-          <p:cNvSpPr/>
-          <p:nvPr/>
-        </p:nvSpPr>
-        <p:spPr>
-          <a:xfrm>
-            <a:off x="7772400" y="4709160"/>
-            <a:ext cx="1097280" cy="320040"/>
+          <p:cNvPr id="5" name="Text 3"/>
+          <p:cNvSpPr/>
+          <p:nvPr/>
+        </p:nvSpPr>
+        <p:spPr>
+          <a:xfrm>
+            <a:off x="777240" y="137160"/>
+            <a:ext cx="7772400" cy="548640"/>
           </a:xfrm>
           <a:prstGeom prst="rect">
             <a:avLst/>
@@ -1684,53 +2628,14 @@
           <a:ln/>
         </p:spPr>
         <p:txBody>
-          <a:bodyPr wrap="square" rtlCol="0" anchor="ctr"/>
-          <a:lstStyle/>
-          <a:p>
-            <a:pPr algn="r" indent="0" marL="0">
-              <a:buNone/>
-            </a:pPr>
-            <a:r>
-              <a:rPr lang="en-US" sz="900" dirty="0">
-                <a:solidFill>
-                  <a:srgbClr val="6B6660"/>
-                </a:solidFill>
-                <a:latin typeface="Calibri" pitchFamily="34" charset="0"/>
-                <a:ea typeface="Calibri" pitchFamily="34" charset="-122"/>
-                <a:cs typeface="Calibri" pitchFamily="34" charset="-120"/>
-              </a:rPr>
-              <a:t>3 / 5</a:t>
-            </a:r>
-            <a:endParaRPr lang="en-US" sz="900" dirty="0"/>
-          </a:p>
-        </p:txBody>
-      </p:sp>
-      <p:sp>
-        <p:nvSpPr>
-          <p:cNvPr id="4" name="Text 2"/>
-          <p:cNvSpPr/>
-          <p:nvPr/>
-        </p:nvSpPr>
-        <p:spPr>
-          <a:xfrm>
-            <a:off x="457200" y="274320"/>
-            <a:ext cx="8229600" cy="640080"/>
-          </a:xfrm>
-          <a:prstGeom prst="rect">
-            <a:avLst/>
-          </a:prstGeom>
-          <a:noFill/>
-          <a:ln/>
-        </p:spPr>
-        <p:txBody>
-          <a:bodyPr wrap="square" rtlCol="0" anchor="ctr"/>
+          <a:bodyPr wrap="square" lIns="0" tIns="0" rIns="0" bIns="0" rtlCol="0" anchor="ctr"/>
           <a:lstStyle/>
           <a:p>
             <a:pPr indent="0" marL="0">
               <a:buNone/>
             </a:pPr>
             <a:r>
-              <a:rPr lang="en-US" sz="2600" b="1" dirty="0">
+              <a:rPr lang="en-US" sz="2000" b="1" dirty="0">
                 <a:solidFill>
                   <a:srgbClr val="1B2A4A"/>
                 </a:solidFill>
@@ -1738,22 +2643,22 @@
                 <a:ea typeface="Georgia" pitchFamily="34" charset="-122"/>
                 <a:cs typeface="Georgia" pitchFamily="34" charset="-120"/>
               </a:rPr>
-              <a:t>Key Definitions</a:t>
-            </a:r>
-            <a:endParaRPr lang="en-US" sz="2600" dirty="0"/>
-          </a:p>
-        </p:txBody>
-      </p:sp>
-      <p:sp>
-        <p:nvSpPr>
-          <p:cNvPr id="5" name="Shape 3"/>
-          <p:cNvSpPr/>
-          <p:nvPr/>
-        </p:nvSpPr>
-        <p:spPr>
-          <a:xfrm>
-            <a:off x="457200" y="1188720"/>
-            <a:ext cx="2560320" cy="1828800"/>
+              <a:t>Factors vs Multiples</a:t>
+            </a:r>
+            <a:endParaRPr lang="en-US" sz="2000" dirty="0"/>
+          </a:p>
+        </p:txBody>
+      </p:sp>
+      <p:sp>
+        <p:nvSpPr>
+          <p:cNvPr id="6" name="Shape 4"/>
+          <p:cNvSpPr/>
+          <p:nvPr/>
+        </p:nvSpPr>
+        <p:spPr>
+          <a:xfrm>
+            <a:off x="548640" y="1051560"/>
+            <a:ext cx="3840480" cy="3474720"/>
           </a:xfrm>
           <a:prstGeom prst="rect">
             <a:avLst/>
@@ -1761,12 +2666,7 @@
           <a:solidFill>
             <a:srgbClr val="FFFFFF"/>
           </a:solidFill>
-          <a:ln w="12700">
-            <a:solidFill>
-              <a:srgbClr val="E5E2DC"/>
-            </a:solidFill>
-            <a:prstDash val="solid"/>
-          </a:ln>
+          <a:ln/>
           <a:effectLst>
             <a:outerShdw sx="100000" sy="100000" kx="0" ky="0" algn="bl" rotWithShape="0" blurRad="50800" dist="25400" dir="8100000">
               <a:srgbClr val="000000">
@@ -1778,14 +2678,14 @@
       </p:sp>
       <p:sp>
         <p:nvSpPr>
-          <p:cNvPr id="6" name="Shape 4"/>
-          <p:cNvSpPr/>
-          <p:nvPr/>
-        </p:nvSpPr>
-        <p:spPr>
-          <a:xfrm>
-            <a:off x="457200" y="1188720"/>
-            <a:ext cx="2560320" cy="54864"/>
+          <p:cNvPr id="7" name="Shape 5"/>
+          <p:cNvSpPr/>
+          <p:nvPr/>
+        </p:nvSpPr>
+        <p:spPr>
+          <a:xfrm>
+            <a:off x="548640" y="1051560"/>
+            <a:ext cx="3840480" cy="54864"/>
           </a:xfrm>
           <a:prstGeom prst="rect">
             <a:avLst/>
@@ -1798,14 +2698,14 @@
       </p:sp>
       <p:sp>
         <p:nvSpPr>
-          <p:cNvPr id="7" name="Text 5"/>
-          <p:cNvSpPr/>
-          <p:nvPr/>
-        </p:nvSpPr>
-        <p:spPr>
-          <a:xfrm>
-            <a:off x="594360" y="1325880"/>
-            <a:ext cx="2286000" cy="365760"/>
+          <p:cNvPr id="8" name="Text 6"/>
+          <p:cNvSpPr/>
+          <p:nvPr/>
+        </p:nvSpPr>
+        <p:spPr>
+          <a:xfrm>
+            <a:off x="777240" y="1188720"/>
+            <a:ext cx="3383280" cy="457200"/>
           </a:xfrm>
           <a:prstGeom prst="rect">
             <a:avLst/>
@@ -1814,53 +2714,78 @@
           <a:ln/>
         </p:spPr>
         <p:txBody>
-          <a:bodyPr wrap="square" rtlCol="0" anchor="ctr"/>
+          <a:bodyPr wrap="square" lIns="0" tIns="0" rIns="0" bIns="0" rtlCol="0" anchor="ctr"/>
           <a:lstStyle/>
           <a:p>
             <a:pPr indent="0" marL="0">
               <a:buNone/>
             </a:pPr>
             <a:r>
-              <a:rPr lang="en-US" sz="1400" b="1" dirty="0">
+              <a:rPr lang="en-US" sz="1500" b="1" dirty="0">
                 <a:solidFill>
                   <a:srgbClr val="1B2A4A"/>
+                </a:solidFill>
+                <a:latin typeface="Georgia" pitchFamily="34" charset="0"/>
+                <a:ea typeface="Georgia" pitchFamily="34" charset="-122"/>
+                <a:cs typeface="Georgia" pitchFamily="34" charset="-120"/>
+              </a:rPr>
+              <a:t>Factors</a:t>
+            </a:r>
+            <a:endParaRPr lang="en-US" sz="1500" dirty="0"/>
+          </a:p>
+        </p:txBody>
+      </p:sp>
+      <p:sp>
+        <p:nvSpPr>
+          <p:cNvPr id="9" name="Text 7"/>
+          <p:cNvSpPr/>
+          <p:nvPr/>
+        </p:nvSpPr>
+        <p:spPr>
+          <a:xfrm>
+            <a:off x="777240" y="1691640"/>
+            <a:ext cx="3383280" cy="2651760"/>
+          </a:xfrm>
+          <a:prstGeom prst="rect">
+            <a:avLst/>
+          </a:prstGeom>
+          <a:noFill/>
+          <a:ln/>
+        </p:spPr>
+        <p:txBody>
+          <a:bodyPr wrap="square" rtlCol="0" anchor="t"/>
+          <a:lstStyle/>
+          <a:p>
+            <a:pPr marL="342900" indent="-342900">
+              <a:spcAft>
+                <a:spcPts val="600"/>
+              </a:spcAft>
+              <a:buSzPct val="100000"/>
+              <a:buChar char="•"/>
+            </a:pPr>
+            <a:r>
+              <a:rPr lang="en-US" sz="1300" dirty="0">
+                <a:solidFill>
+                  <a:srgbClr val="3D3A36"/>
                 </a:solidFill>
                 <a:latin typeface="Calibri" pitchFamily="34" charset="0"/>
                 <a:ea typeface="Calibri" pitchFamily="34" charset="-122"/>
                 <a:cs typeface="Calibri" pitchFamily="34" charset="-120"/>
               </a:rPr>
-              <a:t>Factors</a:t>
-            </a:r>
-            <a:endParaRPr lang="en-US" sz="1400" dirty="0"/>
-          </a:p>
-        </p:txBody>
-      </p:sp>
-      <p:sp>
-        <p:nvSpPr>
-          <p:cNvPr id="8" name="Text 6"/>
-          <p:cNvSpPr/>
-          <p:nvPr/>
-        </p:nvSpPr>
-        <p:spPr>
-          <a:xfrm>
-            <a:off x="594360" y="1737360"/>
-            <a:ext cx="2286000" cy="1097280"/>
-          </a:xfrm>
-          <a:prstGeom prst="rect">
-            <a:avLst/>
-          </a:prstGeom>
-          <a:noFill/>
-          <a:ln/>
-        </p:spPr>
-        <p:txBody>
-          <a:bodyPr wrap="square" rtlCol="0" anchor="t"/>
-          <a:lstStyle/>
-          <a:p>
-            <a:pPr indent="0" marL="0">
-              <a:buNone/>
-            </a:pPr>
-            <a:r>
-              <a:rPr lang="en-US" sz="1100" dirty="0">
+              <a:t>Numbers that divide INTO a number exactly</a:t>
+            </a:r>
+            <a:endParaRPr lang="en-US" sz="1300" dirty="0"/>
+          </a:p>
+          <a:p>
+            <a:pPr marL="342900" indent="-342900">
+              <a:spcAft>
+                <a:spcPts val="600"/>
+              </a:spcAft>
+              <a:buSzPct val="100000"/>
+              <a:buChar char="•"/>
+            </a:pPr>
+            <a:r>
+              <a:rPr lang="en-US" sz="1300" dirty="0">
                 <a:solidFill>
                   <a:srgbClr val="3D3A36"/>
                 </a:solidFill>
@@ -1868,22 +2793,85 @@
                 <a:ea typeface="Calibri" pitchFamily="34" charset="-122"/>
                 <a:cs typeface="Calibri" pitchFamily="34" charset="-120"/>
               </a:rPr>
-              <a:t>Numbers that divide exactly into another number. Factors of 12: 1, 2, 3, 4, 6, 12. Every number has at least two factors: 1 and itself.</a:t>
-            </a:r>
-            <a:endParaRPr lang="en-US" sz="1100" dirty="0"/>
-          </a:p>
-        </p:txBody>
-      </p:sp>
-      <p:sp>
-        <p:nvSpPr>
-          <p:cNvPr id="9" name="Shape 7"/>
-          <p:cNvSpPr/>
-          <p:nvPr/>
-        </p:nvSpPr>
-        <p:spPr>
-          <a:xfrm>
-            <a:off x="3291840" y="1188720"/>
-            <a:ext cx="2560320" cy="1828800"/>
+              <a:t>Factors of 12: 1, 2, 3, 4, 6, 12</a:t>
+            </a:r>
+            <a:endParaRPr lang="en-US" sz="1300" dirty="0"/>
+          </a:p>
+          <a:p>
+            <a:pPr marL="342900" indent="-342900">
+              <a:spcAft>
+                <a:spcPts val="600"/>
+              </a:spcAft>
+              <a:buSzPct val="100000"/>
+              <a:buChar char="•"/>
+            </a:pPr>
+            <a:r>
+              <a:rPr lang="en-US" sz="1300" dirty="0">
+                <a:solidFill>
+                  <a:srgbClr val="3D3A36"/>
+                </a:solidFill>
+                <a:latin typeface="Calibri" pitchFamily="34" charset="0"/>
+                <a:ea typeface="Calibri" pitchFamily="34" charset="-122"/>
+                <a:cs typeface="Calibri" pitchFamily="34" charset="-120"/>
+              </a:rPr>
+              <a:t>Always start from 1 and the number itself</a:t>
+            </a:r>
+            <a:endParaRPr lang="en-US" sz="1300" dirty="0"/>
+          </a:p>
+          <a:p>
+            <a:pPr marL="342900" indent="-342900">
+              <a:spcAft>
+                <a:spcPts val="600"/>
+              </a:spcAft>
+              <a:buSzPct val="100000"/>
+              <a:buChar char="•"/>
+            </a:pPr>
+            <a:r>
+              <a:rPr lang="en-US" sz="1300" dirty="0">
+                <a:solidFill>
+                  <a:srgbClr val="3D3A36"/>
+                </a:solidFill>
+                <a:latin typeface="Calibri" pitchFamily="34" charset="0"/>
+                <a:ea typeface="Calibri" pitchFamily="34" charset="-122"/>
+                <a:cs typeface="Calibri" pitchFamily="34" charset="-120"/>
+              </a:rPr>
+              <a:t>Work in pairs: 1×12, 2×6, 3×4</a:t>
+            </a:r>
+            <a:endParaRPr lang="en-US" sz="1300" dirty="0"/>
+          </a:p>
+          <a:p>
+            <a:pPr marL="342900" indent="-342900">
+              <a:spcAft>
+                <a:spcPts val="600"/>
+              </a:spcAft>
+              <a:buSzPct val="100000"/>
+              <a:buChar char="•"/>
+            </a:pPr>
+            <a:r>
+              <a:rPr lang="en-US" sz="1300" dirty="0">
+                <a:solidFill>
+                  <a:srgbClr val="3D3A36"/>
+                </a:solidFill>
+                <a:latin typeface="Calibri" pitchFamily="34" charset="0"/>
+                <a:ea typeface="Calibri" pitchFamily="34" charset="-122"/>
+                <a:cs typeface="Calibri" pitchFamily="34" charset="-120"/>
+              </a:rPr>
+              <a:t>Factors get SMALLER — there's a fixed set</a:t>
+            </a:r>
+            <a:endParaRPr lang="en-US" sz="1300" dirty="0"/>
+          </a:p>
+        </p:txBody>
+      </p:sp>
+      <p:sp>
+        <p:nvSpPr>
+          <p:cNvPr id="10" name="Shape 8"/>
+          <p:cNvSpPr/>
+          <p:nvPr/>
+        </p:nvSpPr>
+        <p:spPr>
+          <a:xfrm>
+            <a:off x="4754880" y="1051560"/>
+            <a:ext cx="3840480" cy="3474720"/>
           </a:xfrm>
           <a:prstGeom prst="rect">
             <a:avLst/>
@@ -1891,12 +2879,7 @@
           <a:solidFill>
             <a:srgbClr val="FFFFFF"/>
           </a:solidFill>
-          <a:ln w="12700">
-            <a:solidFill>
-              <a:srgbClr val="E5E2DC"/>
-            </a:solidFill>
-            <a:prstDash val="solid"/>
-          </a:ln>
+          <a:ln/>
           <a:effectLst>
             <a:outerShdw sx="100000" sy="100000" kx="0" ky="0" algn="bl" rotWithShape="0" blurRad="50800" dist="25400" dir="8100000">
               <a:srgbClr val="000000">
@@ -1908,34 +2891,34 @@
       </p:sp>
       <p:sp>
         <p:nvSpPr>
-          <p:cNvPr id="10" name="Shape 8"/>
-          <p:cNvSpPr/>
-          <p:nvPr/>
-        </p:nvSpPr>
-        <p:spPr>
-          <a:xfrm>
-            <a:off x="3291840" y="1188720"/>
-            <a:ext cx="2560320" cy="54864"/>
-          </a:xfrm>
-          <a:prstGeom prst="rect">
-            <a:avLst/>
-          </a:prstGeom>
-          <a:solidFill>
-            <a:srgbClr val="2A9D8F"/>
-          </a:solidFill>
-          <a:ln/>
-        </p:spPr>
-      </p:sp>
-      <p:sp>
-        <p:nvSpPr>
-          <p:cNvPr id="11" name="Text 9"/>
-          <p:cNvSpPr/>
-          <p:nvPr/>
-        </p:nvSpPr>
-        <p:spPr>
-          <a:xfrm>
-            <a:off x="3429000" y="1325880"/>
-            <a:ext cx="2286000" cy="365760"/>
+          <p:cNvPr id="11" name="Shape 9"/>
+          <p:cNvSpPr/>
+          <p:nvPr/>
+        </p:nvSpPr>
+        <p:spPr>
+          <a:xfrm>
+            <a:off x="4754880" y="1051560"/>
+            <a:ext cx="3840480" cy="54864"/>
+          </a:xfrm>
+          <a:prstGeom prst="rect">
+            <a:avLst/>
+          </a:prstGeom>
+          <a:solidFill>
+            <a:srgbClr val="E9C46A"/>
+          </a:solidFill>
+          <a:ln/>
+        </p:spPr>
+      </p:sp>
+      <p:sp>
+        <p:nvSpPr>
+          <p:cNvPr id="12" name="Text 10"/>
+          <p:cNvSpPr/>
+          <p:nvPr/>
+        </p:nvSpPr>
+        <p:spPr>
+          <a:xfrm>
+            <a:off x="4983480" y="1188720"/>
+            <a:ext cx="3383280" cy="457200"/>
           </a:xfrm>
           <a:prstGeom prst="rect">
             <a:avLst/>
@@ -1944,53 +2927,78 @@
           <a:ln/>
         </p:spPr>
         <p:txBody>
-          <a:bodyPr wrap="square" rtlCol="0" anchor="ctr"/>
+          <a:bodyPr wrap="square" lIns="0" tIns="0" rIns="0" bIns="0" rtlCol="0" anchor="ctr"/>
           <a:lstStyle/>
           <a:p>
             <a:pPr indent="0" marL="0">
               <a:buNone/>
             </a:pPr>
             <a:r>
-              <a:rPr lang="en-US" sz="1400" b="1" dirty="0">
+              <a:rPr lang="en-US" sz="1500" b="1" dirty="0">
                 <a:solidFill>
                   <a:srgbClr val="1B2A4A"/>
+                </a:solidFill>
+                <a:latin typeface="Georgia" pitchFamily="34" charset="0"/>
+                <a:ea typeface="Georgia" pitchFamily="34" charset="-122"/>
+                <a:cs typeface="Georgia" pitchFamily="34" charset="-120"/>
+              </a:rPr>
+              <a:t>Multiples</a:t>
+            </a:r>
+            <a:endParaRPr lang="en-US" sz="1500" dirty="0"/>
+          </a:p>
+        </p:txBody>
+      </p:sp>
+      <p:sp>
+        <p:nvSpPr>
+          <p:cNvPr id="13" name="Text 11"/>
+          <p:cNvSpPr/>
+          <p:nvPr/>
+        </p:nvSpPr>
+        <p:spPr>
+          <a:xfrm>
+            <a:off x="4983480" y="1691640"/>
+            <a:ext cx="3383280" cy="2651760"/>
+          </a:xfrm>
+          <a:prstGeom prst="rect">
+            <a:avLst/>
+          </a:prstGeom>
+          <a:noFill/>
+          <a:ln/>
+        </p:spPr>
+        <p:txBody>
+          <a:bodyPr wrap="square" rtlCol="0" anchor="t"/>
+          <a:lstStyle/>
+          <a:p>
+            <a:pPr marL="342900" indent="-342900">
+              <a:spcAft>
+                <a:spcPts val="600"/>
+              </a:spcAft>
+              <a:buSzPct val="100000"/>
+              <a:buChar char="•"/>
+            </a:pPr>
+            <a:r>
+              <a:rPr lang="en-US" sz="1300" dirty="0">
+                <a:solidFill>
+                  <a:srgbClr val="3D3A36"/>
                 </a:solidFill>
                 <a:latin typeface="Calibri" pitchFamily="34" charset="0"/>
                 <a:ea typeface="Calibri" pitchFamily="34" charset="-122"/>
                 <a:cs typeface="Calibri" pitchFamily="34" charset="-120"/>
               </a:rPr>
-              <a:t>Multiples</a:t>
-            </a:r>
-            <a:endParaRPr lang="en-US" sz="1400" dirty="0"/>
-          </a:p>
-        </p:txBody>
-      </p:sp>
-      <p:sp>
-        <p:nvSpPr>
-          <p:cNvPr id="12" name="Text 10"/>
-          <p:cNvSpPr/>
-          <p:nvPr/>
-        </p:nvSpPr>
-        <p:spPr>
-          <a:xfrm>
-            <a:off x="3429000" y="1737360"/>
-            <a:ext cx="2286000" cy="1097280"/>
-          </a:xfrm>
-          <a:prstGeom prst="rect">
-            <a:avLst/>
-          </a:prstGeom>
-          <a:noFill/>
-          <a:ln/>
-        </p:spPr>
-        <p:txBody>
-          <a:bodyPr wrap="square" rtlCol="0" anchor="t"/>
-          <a:lstStyle/>
-          <a:p>
-            <a:pPr indent="0" marL="0">
-              <a:buNone/>
-            </a:pPr>
-            <a:r>
-              <a:rPr lang="en-US" sz="1100" dirty="0">
+              <a:t>The TIMES TABLE of a number</a:t>
+            </a:r>
+            <a:endParaRPr lang="en-US" sz="1300" dirty="0"/>
+          </a:p>
+          <a:p>
+            <a:pPr marL="342900" indent="-342900">
+              <a:spcAft>
+                <a:spcPts val="600"/>
+              </a:spcAft>
+              <a:buSzPct val="100000"/>
+              <a:buChar char="•"/>
+            </a:pPr>
+            <a:r>
+              <a:rPr lang="en-US" sz="1300" dirty="0">
                 <a:solidFill>
                   <a:srgbClr val="3D3A36"/>
                 </a:solidFill>
@@ -1998,129 +3006,41 @@
                 <a:ea typeface="Calibri" pitchFamily="34" charset="-122"/>
                 <a:cs typeface="Calibri" pitchFamily="34" charset="-120"/>
               </a:rPr>
-              <a:t>The 'times table' results. Multiples of 5: 5, 10, 15, 20, 25... A multiple = the number × any whole number.</a:t>
-            </a:r>
-            <a:endParaRPr lang="en-US" sz="1100" dirty="0"/>
-          </a:p>
-        </p:txBody>
-      </p:sp>
-      <p:sp>
-        <p:nvSpPr>
-          <p:cNvPr id="13" name="Shape 11"/>
-          <p:cNvSpPr/>
-          <p:nvPr/>
-        </p:nvSpPr>
-        <p:spPr>
-          <a:xfrm>
-            <a:off x="6126480" y="1188720"/>
-            <a:ext cx="2560320" cy="1828800"/>
-          </a:xfrm>
-          <a:prstGeom prst="rect">
-            <a:avLst/>
-          </a:prstGeom>
-          <a:solidFill>
-            <a:srgbClr val="FFFFFF"/>
-          </a:solidFill>
-          <a:ln w="12700">
-            <a:solidFill>
-              <a:srgbClr val="E5E2DC"/>
-            </a:solidFill>
-            <a:prstDash val="solid"/>
-          </a:ln>
-          <a:effectLst>
-            <a:outerShdw sx="100000" sy="100000" kx="0" ky="0" algn="bl" rotWithShape="0" blurRad="50800" dist="25400" dir="8100000">
-              <a:srgbClr val="000000">
-                <a:alpha val="10000"/>
-              </a:srgbClr>
-            </a:outerShdw>
-          </a:effectLst>
-        </p:spPr>
-      </p:sp>
-      <p:sp>
-        <p:nvSpPr>
-          <p:cNvPr id="14" name="Shape 12"/>
-          <p:cNvSpPr/>
-          <p:nvPr/>
-        </p:nvSpPr>
-        <p:spPr>
-          <a:xfrm>
-            <a:off x="6126480" y="1188720"/>
-            <a:ext cx="2560320" cy="54864"/>
-          </a:xfrm>
-          <a:prstGeom prst="rect">
-            <a:avLst/>
-          </a:prstGeom>
-          <a:solidFill>
-            <a:srgbClr val="2A9D8F"/>
-          </a:solidFill>
-          <a:ln/>
-        </p:spPr>
-      </p:sp>
-      <p:sp>
-        <p:nvSpPr>
-          <p:cNvPr id="15" name="Text 13"/>
-          <p:cNvSpPr/>
-          <p:nvPr/>
-        </p:nvSpPr>
-        <p:spPr>
-          <a:xfrm>
-            <a:off x="6263640" y="1325880"/>
-            <a:ext cx="2286000" cy="365760"/>
-          </a:xfrm>
-          <a:prstGeom prst="rect">
-            <a:avLst/>
-          </a:prstGeom>
-          <a:noFill/>
-          <a:ln/>
-        </p:spPr>
-        <p:txBody>
-          <a:bodyPr wrap="square" rtlCol="0" anchor="ctr"/>
-          <a:lstStyle/>
-          <a:p>
-            <a:pPr indent="0" marL="0">
-              <a:buNone/>
-            </a:pPr>
-            <a:r>
-              <a:rPr lang="en-US" sz="1400" b="1" dirty="0">
-                <a:solidFill>
-                  <a:srgbClr val="1B2A4A"/>
+              <a:t>Multiples of 3: 3, 6, 9, 12, 15, 18...</a:t>
+            </a:r>
+            <a:endParaRPr lang="en-US" sz="1300" dirty="0"/>
+          </a:p>
+          <a:p>
+            <a:pPr marL="342900" indent="-342900">
+              <a:spcAft>
+                <a:spcPts val="600"/>
+              </a:spcAft>
+              <a:buSzPct val="100000"/>
+              <a:buChar char="•"/>
+            </a:pPr>
+            <a:r>
+              <a:rPr lang="en-US" sz="1300" dirty="0">
+                <a:solidFill>
+                  <a:srgbClr val="3D3A36"/>
                 </a:solidFill>
                 <a:latin typeface="Calibri" pitchFamily="34" charset="0"/>
                 <a:ea typeface="Calibri" pitchFamily="34" charset="-122"/>
                 <a:cs typeface="Calibri" pitchFamily="34" charset="-120"/>
               </a:rPr>
-              <a:t>Prime Numbers</a:t>
-            </a:r>
-            <a:endParaRPr lang="en-US" sz="1400" dirty="0"/>
-          </a:p>
-        </p:txBody>
-      </p:sp>
-      <p:sp>
-        <p:nvSpPr>
-          <p:cNvPr id="16" name="Text 14"/>
-          <p:cNvSpPr/>
-          <p:nvPr/>
-        </p:nvSpPr>
-        <p:spPr>
-          <a:xfrm>
-            <a:off x="6263640" y="1737360"/>
-            <a:ext cx="2286000" cy="1097280"/>
-          </a:xfrm>
-          <a:prstGeom prst="rect">
-            <a:avLst/>
-          </a:prstGeom>
-          <a:noFill/>
-          <a:ln/>
-        </p:spPr>
-        <p:txBody>
-          <a:bodyPr wrap="square" rtlCol="0" anchor="t"/>
-          <a:lstStyle/>
-          <a:p>
-            <a:pPr indent="0" marL="0">
-              <a:buNone/>
-            </a:pPr>
-            <a:r>
-              <a:rPr lang="en-US" sz="1100" dirty="0">
+              <a:t>Start from the number and keep adding</a:t>
+            </a:r>
+            <a:endParaRPr lang="en-US" sz="1300" dirty="0"/>
+          </a:p>
+          <a:p>
+            <a:pPr marL="342900" indent="-342900">
+              <a:spcAft>
+                <a:spcPts val="600"/>
+              </a:spcAft>
+              <a:buSzPct val="100000"/>
+              <a:buChar char="•"/>
+            </a:pPr>
+            <a:r>
+              <a:rPr lang="en-US" sz="1300" dirty="0">
                 <a:solidFill>
                   <a:srgbClr val="3D3A36"/>
                 </a:solidFill>
@@ -2128,9 +3048,30 @@
                 <a:ea typeface="Calibri" pitchFamily="34" charset="-122"/>
                 <a:cs typeface="Calibri" pitchFamily="34" charset="-120"/>
               </a:rPr>
-              <a:t>A number with EXACTLY two factors: 1 and itself. First primes: 2, 3, 5, 7, 11, 13, 17, 19, 23, 29. Note: 1 is NOT prime (only one factor). 2 is the only even prime.</a:t>
-            </a:r>
-            <a:endParaRPr lang="en-US" sz="1100" dirty="0"/>
+              <a:t>Multiples go on FOREVER</a:t>
+            </a:r>
+            <a:endParaRPr lang="en-US" sz="1300" dirty="0"/>
+          </a:p>
+          <a:p>
+            <a:pPr marL="342900" indent="-342900">
+              <a:spcAft>
+                <a:spcPts val="600"/>
+              </a:spcAft>
+              <a:buSzPct val="100000"/>
+              <a:buChar char="•"/>
+            </a:pPr>
+            <a:r>
+              <a:rPr lang="en-US" sz="1300" dirty="0">
+                <a:solidFill>
+                  <a:srgbClr val="3D3A36"/>
+                </a:solidFill>
+                <a:latin typeface="Calibri" pitchFamily="34" charset="0"/>
+                <a:ea typeface="Calibri" pitchFamily="34" charset="-122"/>
+                <a:cs typeface="Calibri" pitchFamily="34" charset="-120"/>
+              </a:rPr>
+              <a:t>Every number has infinite multiples</a:t>
+            </a:r>
+            <a:endParaRPr lang="en-US" sz="1300" dirty="0"/>
           </a:p>
         </p:txBody>
       </p:sp>
@@ -2175,7 +3116,47 @@
         <p:spPr>
           <a:xfrm>
             <a:off x="0" y="0"/>
-            <a:ext cx="9144000" cy="54864"/>
+            <a:ext cx="9144000" cy="822960"/>
+          </a:xfrm>
+          <a:prstGeom prst="rect">
+            <a:avLst/>
+          </a:prstGeom>
+          <a:solidFill>
+            <a:srgbClr val="FFFFFF"/>
+          </a:solidFill>
+          <a:ln/>
+        </p:spPr>
+      </p:sp>
+      <p:sp>
+        <p:nvSpPr>
+          <p:cNvPr id="3" name="Shape 1"/>
+          <p:cNvSpPr/>
+          <p:nvPr/>
+        </p:nvSpPr>
+        <p:spPr>
+          <a:xfrm>
+            <a:off x="0" y="804672"/>
+            <a:ext cx="9144000" cy="27432"/>
+          </a:xfrm>
+          <a:prstGeom prst="rect">
+            <a:avLst/>
+          </a:prstGeom>
+          <a:solidFill>
+            <a:srgbClr val="E5E2DC"/>
+          </a:solidFill>
+          <a:ln/>
+        </p:spPr>
+      </p:sp>
+      <p:sp>
+        <p:nvSpPr>
+          <p:cNvPr id="4" name="Shape 2"/>
+          <p:cNvSpPr/>
+          <p:nvPr/>
+        </p:nvSpPr>
+        <p:spPr>
+          <a:xfrm>
+            <a:off x="548640" y="201168"/>
+            <a:ext cx="54864" cy="420624"/>
           </a:xfrm>
           <a:prstGeom prst="rect">
             <a:avLst/>
@@ -2188,14 +3169,14 @@
       </p:sp>
       <p:sp>
         <p:nvSpPr>
-          <p:cNvPr id="3" name="Text 1"/>
-          <p:cNvSpPr/>
-          <p:nvPr/>
-        </p:nvSpPr>
-        <p:spPr>
-          <a:xfrm>
-            <a:off x="7772400" y="4709160"/>
-            <a:ext cx="1097280" cy="320040"/>
+          <p:cNvPr id="5" name="Text 3"/>
+          <p:cNvSpPr/>
+          <p:nvPr/>
+        </p:nvSpPr>
+        <p:spPr>
+          <a:xfrm>
+            <a:off x="777240" y="137160"/>
+            <a:ext cx="7772400" cy="548640"/>
           </a:xfrm>
           <a:prstGeom prst="rect">
             <a:avLst/>
@@ -2204,96 +3185,78 @@
           <a:ln/>
         </p:spPr>
         <p:txBody>
-          <a:bodyPr wrap="square" rtlCol="0" anchor="ctr"/>
-          <a:lstStyle/>
-          <a:p>
-            <a:pPr algn="r" indent="0" marL="0">
+          <a:bodyPr wrap="square" lIns="0" tIns="0" rIns="0" bIns="0" rtlCol="0" anchor="ctr"/>
+          <a:lstStyle/>
+          <a:p>
+            <a:pPr indent="0" marL="0">
               <a:buNone/>
             </a:pPr>
             <a:r>
-              <a:rPr lang="en-US" sz="900" dirty="0">
-                <a:solidFill>
-                  <a:srgbClr val="6B6660"/>
+              <a:rPr lang="en-US" sz="2000" b="1" dirty="0">
+                <a:solidFill>
+                  <a:srgbClr val="1B2A4A"/>
+                </a:solidFill>
+                <a:latin typeface="Georgia" pitchFamily="34" charset="0"/>
+                <a:ea typeface="Georgia" pitchFamily="34" charset="-122"/>
+                <a:cs typeface="Georgia" pitchFamily="34" charset="-120"/>
+              </a:rPr>
+              <a:t>Prime Numbers</a:t>
+            </a:r>
+            <a:endParaRPr lang="en-US" sz="2000" dirty="0"/>
+          </a:p>
+        </p:txBody>
+      </p:sp>
+      <p:sp>
+        <p:nvSpPr>
+          <p:cNvPr id="6" name="Text 4"/>
+          <p:cNvSpPr/>
+          <p:nvPr/>
+        </p:nvSpPr>
+        <p:spPr>
+          <a:xfrm>
+            <a:off x="731520" y="1051560"/>
+            <a:ext cx="7680960" cy="3108960"/>
+          </a:xfrm>
+          <a:prstGeom prst="rect">
+            <a:avLst/>
+          </a:prstGeom>
+          <a:noFill/>
+          <a:ln/>
+        </p:spPr>
+        <p:txBody>
+          <a:bodyPr wrap="square" rtlCol="0" anchor="t"/>
+          <a:lstStyle/>
+          <a:p>
+            <a:pPr marL="342900" indent="-342900">
+              <a:spcAft>
+                <a:spcPts val="800"/>
+              </a:spcAft>
+              <a:buSzPct val="100000"/>
+              <a:buChar char="•"/>
+            </a:pPr>
+            <a:r>
+              <a:rPr lang="en-US" sz="1500" dirty="0">
+                <a:solidFill>
+                  <a:srgbClr val="3D3A36"/>
                 </a:solidFill>
                 <a:latin typeface="Calibri" pitchFamily="34" charset="0"/>
                 <a:ea typeface="Calibri" pitchFamily="34" charset="-122"/>
                 <a:cs typeface="Calibri" pitchFamily="34" charset="-120"/>
               </a:rPr>
-              <a:t>4 / 5</a:t>
-            </a:r>
-            <a:endParaRPr lang="en-US" sz="900" dirty="0"/>
-          </a:p>
-        </p:txBody>
-      </p:sp>
-      <p:sp>
-        <p:nvSpPr>
-          <p:cNvPr id="4" name="Text 2"/>
-          <p:cNvSpPr/>
-          <p:nvPr/>
-        </p:nvSpPr>
-        <p:spPr>
-          <a:xfrm>
-            <a:off x="457200" y="274320"/>
-            <a:ext cx="8229600" cy="640080"/>
-          </a:xfrm>
-          <a:prstGeom prst="rect">
-            <a:avLst/>
-          </a:prstGeom>
-          <a:noFill/>
-          <a:ln/>
-        </p:spPr>
-        <p:txBody>
-          <a:bodyPr wrap="square" rtlCol="0" anchor="ctr"/>
-          <a:lstStyle/>
-          <a:p>
-            <a:pPr indent="0" marL="0">
-              <a:buNone/>
-            </a:pPr>
-            <a:r>
-              <a:rPr lang="en-US" sz="2600" b="1" dirty="0">
-                <a:solidFill>
-                  <a:srgbClr val="1B2A4A"/>
-                </a:solidFill>
-                <a:latin typeface="Georgia" pitchFamily="34" charset="0"/>
-                <a:ea typeface="Georgia" pitchFamily="34" charset="-122"/>
-                <a:cs typeface="Georgia" pitchFamily="34" charset="-120"/>
-              </a:rPr>
-              <a:t>HCF and LCM</a:t>
-            </a:r>
-            <a:endParaRPr lang="en-US" sz="2600" dirty="0"/>
-          </a:p>
-        </p:txBody>
-      </p:sp>
-      <p:sp>
-        <p:nvSpPr>
-          <p:cNvPr id="5" name="Text 3"/>
-          <p:cNvSpPr/>
-          <p:nvPr/>
-        </p:nvSpPr>
-        <p:spPr>
-          <a:xfrm>
-            <a:off x="457200" y="1188720"/>
-            <a:ext cx="3840480" cy="3474720"/>
-          </a:xfrm>
-          <a:prstGeom prst="rect">
-            <a:avLst/>
-          </a:prstGeom>
-          <a:noFill/>
-          <a:ln/>
-        </p:spPr>
-        <p:txBody>
-          <a:bodyPr wrap="square" rtlCol="0" anchor="t"/>
-          <a:lstStyle/>
+              <a:t>A prime number has EXACTLY 2 factors: 1 and itself.</a:t>
+            </a:r>
+            <a:endParaRPr lang="en-US" sz="1500" dirty="0"/>
+          </a:p>
           <a:p>
             <a:pPr marL="342900" indent="-342900">
               <a:spcAft>
-                <a:spcPts val="600"/>
+                <a:spcPts val="800"/>
               </a:spcAft>
               <a:buSzPct val="100000"/>
               <a:buChar char="•"/>
             </a:pPr>
             <a:r>
-              <a:rPr lang="en-US" sz="1400" dirty="0">
+              <a:rPr lang="en-US" sz="1500" dirty="0">
                 <a:solidFill>
                   <a:srgbClr val="3D3A36"/>
                 </a:solidFill>
@@ -2301,20 +3264,20 @@
                 <a:ea typeface="Calibri" pitchFamily="34" charset="-122"/>
                 <a:cs typeface="Calibri" pitchFamily="34" charset="-120"/>
               </a:rPr>
-              <a:t>HCF = Highest Common Factor</a:t>
-            </a:r>
-            <a:endParaRPr lang="en-US" sz="1400" dirty="0"/>
+              <a:t>First primes: 2, 3, 5, 7, 11, 13, 17, 19, 23, 29, 31...</a:t>
+            </a:r>
+            <a:endParaRPr lang="en-US" sz="1500" dirty="0"/>
           </a:p>
           <a:p>
             <a:pPr marL="342900" indent="-342900">
               <a:spcAft>
-                <a:spcPts val="600"/>
+                <a:spcPts val="800"/>
               </a:spcAft>
               <a:buSzPct val="100000"/>
               <a:buChar char="•"/>
             </a:pPr>
             <a:r>
-              <a:rPr lang="en-US" sz="1400" dirty="0">
+              <a:rPr lang="en-US" sz="1500" dirty="0">
                 <a:solidFill>
                   <a:srgbClr val="3D3A36"/>
                 </a:solidFill>
@@ -2322,20 +3285,20 @@
                 <a:ea typeface="Calibri" pitchFamily="34" charset="-122"/>
                 <a:cs typeface="Calibri" pitchFamily="34" charset="-120"/>
               </a:rPr>
-              <a:t>The largest factor shared by two numbers</a:t>
-            </a:r>
-            <a:endParaRPr lang="en-US" sz="1400" dirty="0"/>
+              <a:t>2 is the ONLY even prime number.</a:t>
+            </a:r>
+            <a:endParaRPr lang="en-US" sz="1500" dirty="0"/>
           </a:p>
           <a:p>
             <a:pPr marL="342900" indent="-342900">
               <a:spcAft>
-                <a:spcPts val="600"/>
+                <a:spcPts val="800"/>
               </a:spcAft>
               <a:buSzPct val="100000"/>
               <a:buChar char="•"/>
             </a:pPr>
             <a:r>
-              <a:rPr lang="en-US" sz="1400" dirty="0">
+              <a:rPr lang="en-US" sz="1500" dirty="0">
                 <a:solidFill>
                   <a:srgbClr val="3D3A36"/>
                 </a:solidFill>
@@ -2343,20 +3306,20 @@
                 <a:ea typeface="Calibri" pitchFamily="34" charset="-122"/>
                 <a:cs typeface="Calibri" pitchFamily="34" charset="-120"/>
               </a:rPr>
-              <a:t>HCF of 12 and 18: factors of 12 = 1,2,3,4,6,12; factors of 18 = 1,2,3,6,9,18; common = 1,2,3,6 → HCF = 6</a:t>
-            </a:r>
-            <a:endParaRPr lang="en-US" sz="1400" dirty="0"/>
+              <a:t>1 is NOT prime (it only has one factor).</a:t>
+            </a:r>
+            <a:endParaRPr lang="en-US" sz="1500" dirty="0"/>
           </a:p>
           <a:p>
             <a:pPr marL="342900" indent="-342900">
               <a:spcAft>
-                <a:spcPts val="600"/>
+                <a:spcPts val="800"/>
               </a:spcAft>
               <a:buSzPct val="100000"/>
               <a:buChar char="•"/>
             </a:pPr>
             <a:r>
-              <a:rPr lang="en-US" sz="1400" dirty="0">
+              <a:rPr lang="en-US" sz="1500" dirty="0">
                 <a:solidFill>
                   <a:srgbClr val="3D3A36"/>
                 </a:solidFill>
@@ -2364,77 +3327,30 @@
                 <a:ea typeface="Calibri" pitchFamily="34" charset="-122"/>
                 <a:cs typeface="Calibri" pitchFamily="34" charset="-120"/>
               </a:rPr>
-              <a:t>LCM = Lowest Common Multiple</a:t>
-            </a:r>
-            <a:endParaRPr lang="en-US" sz="1400" dirty="0"/>
-          </a:p>
-          <a:p>
-            <a:pPr marL="342900" indent="-342900">
-              <a:spcAft>
-                <a:spcPts val="600"/>
-              </a:spcAft>
-              <a:buSzPct val="100000"/>
-              <a:buChar char="•"/>
-            </a:pPr>
-            <a:r>
-              <a:rPr lang="en-US" sz="1400" dirty="0">
-                <a:solidFill>
-                  <a:srgbClr val="3D3A36"/>
-                </a:solidFill>
-                <a:latin typeface="Calibri" pitchFamily="34" charset="0"/>
-                <a:ea typeface="Calibri" pitchFamily="34" charset="-122"/>
-                <a:cs typeface="Calibri" pitchFamily="34" charset="-120"/>
-              </a:rPr>
-              <a:t>The smallest multiple shared by two numbers</a:t>
-            </a:r>
-            <a:endParaRPr lang="en-US" sz="1400" dirty="0"/>
-          </a:p>
-          <a:p>
-            <a:pPr marL="342900" indent="-342900">
-              <a:spcAft>
-                <a:spcPts val="600"/>
-              </a:spcAft>
-              <a:buSzPct val="100000"/>
-              <a:buChar char="•"/>
-            </a:pPr>
-            <a:r>
-              <a:rPr lang="en-US" sz="1400" dirty="0">
-                <a:solidFill>
-                  <a:srgbClr val="3D3A36"/>
-                </a:solidFill>
-                <a:latin typeface="Calibri" pitchFamily="34" charset="0"/>
-                <a:ea typeface="Calibri" pitchFamily="34" charset="-122"/>
-                <a:cs typeface="Calibri" pitchFamily="34" charset="-120"/>
-              </a:rPr>
-              <a:t>LCM of 4 and 6: multiples of 4 = 4,8,12,16...; multiples of 6 = 6,12,18...; LCM = 12</a:t>
-            </a:r>
-            <a:endParaRPr lang="en-US" sz="1400" dirty="0"/>
-          </a:p>
-        </p:txBody>
-      </p:sp>
-      <p:sp>
-        <p:nvSpPr>
-          <p:cNvPr id="6" name="Shape 4"/>
-          <p:cNvSpPr/>
-          <p:nvPr/>
-        </p:nvSpPr>
-        <p:spPr>
-          <a:xfrm>
-            <a:off x="4846320" y="1188720"/>
-            <a:ext cx="3840480" cy="3474720"/>
-          </a:xfrm>
-          <a:prstGeom prst="rect">
-            <a:avLst/>
-          </a:prstGeom>
-          <a:solidFill>
-            <a:srgbClr val="FFFFFF"/>
-          </a:solidFill>
-          <a:ln w="12700">
-            <a:solidFill>
-              <a:srgbClr val="E5E2DC"/>
-            </a:solidFill>
-            <a:prstDash val="solid"/>
-          </a:ln>
+              <a:t>Every whole number &gt; 1 is either prime or can be written as a product of primes.</a:t>
+            </a:r>
+            <a:endParaRPr lang="en-US" sz="1500" dirty="0"/>
+          </a:p>
+        </p:txBody>
+      </p:sp>
+      <p:sp>
+        <p:nvSpPr>
+          <p:cNvPr id="7" name="Shape 5"/>
+          <p:cNvSpPr/>
+          <p:nvPr/>
+        </p:nvSpPr>
+        <p:spPr>
+          <a:xfrm>
+            <a:off x="731520" y="4206240"/>
+            <a:ext cx="7680960" cy="640080"/>
+          </a:xfrm>
+          <a:prstGeom prst="rect">
+            <a:avLst/>
+          </a:prstGeom>
+          <a:solidFill>
+            <a:srgbClr val="E8F5F3"/>
+          </a:solidFill>
+          <a:ln/>
           <a:effectLst>
             <a:outerShdw sx="100000" sy="100000" kx="0" ky="0" algn="bl" rotWithShape="0" blurRad="50800" dist="25400" dir="8100000">
               <a:srgbClr val="000000">
@@ -2446,34 +3362,14 @@
       </p:sp>
       <p:sp>
         <p:nvSpPr>
-          <p:cNvPr id="7" name="Shape 5"/>
-          <p:cNvSpPr/>
-          <p:nvPr/>
-        </p:nvSpPr>
-        <p:spPr>
-          <a:xfrm>
-            <a:off x="4846320" y="1188720"/>
-            <a:ext cx="3840480" cy="54864"/>
-          </a:xfrm>
-          <a:prstGeom prst="rect">
-            <a:avLst/>
-          </a:prstGeom>
-          <a:solidFill>
-            <a:srgbClr val="2A9D8F"/>
-          </a:solidFill>
-          <a:ln/>
-        </p:spPr>
-      </p:sp>
-      <p:sp>
-        <p:nvSpPr>
           <p:cNvPr id="8" name="Text 6"/>
           <p:cNvSpPr/>
           <p:nvPr/>
         </p:nvSpPr>
         <p:spPr>
           <a:xfrm>
-            <a:off x="5120640" y="1371600"/>
-            <a:ext cx="3291840" cy="3108960"/>
+            <a:off x="914400" y="4251960"/>
+            <a:ext cx="7315200" cy="548640"/>
           </a:xfrm>
           <a:prstGeom prst="rect">
             <a:avLst/>
@@ -2482,46 +3378,28 @@
           <a:ln/>
         </p:spPr>
         <p:txBody>
-          <a:bodyPr wrap="square" rtlCol="0" anchor="t"/>
+          <a:bodyPr wrap="square" rtlCol="0" anchor="ctr"/>
           <a:lstStyle/>
           <a:p>
             <a:pPr indent="0" marL="0">
-              <a:spcAft>
-                <a:spcPts val="400"/>
-              </a:spcAft>
               <a:buNone/>
             </a:pPr>
             <a:r>
-              <a:rPr lang="en-US" sz="1600" b="1" dirty="0">
-                <a:solidFill>
-                  <a:srgbClr val="1B2A4A"/>
+              <a:rPr lang="en-US" sz="1200" b="1" dirty="0">
+                <a:solidFill>
+                  <a:srgbClr val="2A9D8F"/>
                 </a:solidFill>
                 <a:latin typeface="Calibri" pitchFamily="34" charset="0"/>
                 <a:ea typeface="Calibri" pitchFamily="34" charset="-122"/>
                 <a:cs typeface="Calibri" pitchFamily="34" charset="-120"/>
               </a:rPr>
-              <a:t>Prime Factorisation</a:t>
-            </a:r>
-            <a:endParaRPr lang="en-US" sz="1600" dirty="0"/>
-          </a:p>
-          <a:p>
+              <a:t>Key Idea: </a:t>
+            </a:r>
             <a:pPr indent="0" marL="0">
-              <a:spcAft>
-                <a:spcPts val="400"/>
-              </a:spcAft>
               <a:buNone/>
             </a:pPr>
-            <a:endParaRPr lang="en-US" sz="1600" dirty="0"/>
-          </a:p>
-          <a:p>
-            <a:pPr indent="0" marL="0">
-              <a:spcAft>
-                <a:spcPts val="400"/>
-              </a:spcAft>
-              <a:buNone/>
-            </a:pPr>
-            <a:r>
-              <a:rPr lang="en-US" sz="1300" dirty="0">
+            <a:r>
+              <a:rPr lang="en-US" sz="1200" i="1" dirty="0">
                 <a:solidFill>
                   <a:srgbClr val="3D3A36"/>
                 </a:solidFill>
@@ -2529,109 +3407,9 @@
                 <a:ea typeface="Calibri" pitchFamily="34" charset="-122"/>
                 <a:cs typeface="Calibri" pitchFamily="34" charset="-120"/>
               </a:rPr>
-              <a:t>Breaking a number into its prime factors</a:t>
-            </a:r>
-            <a:endParaRPr lang="en-US" sz="1600" dirty="0"/>
-          </a:p>
-          <a:p>
-            <a:pPr indent="0" marL="0">
-              <a:spcAft>
-                <a:spcPts val="400"/>
-              </a:spcAft>
-              <a:buNone/>
-            </a:pPr>
-            <a:r>
-              <a:rPr lang="en-US" sz="1300" dirty="0">
-                <a:solidFill>
-                  <a:srgbClr val="3D3A36"/>
-                </a:solidFill>
-                <a:latin typeface="Calibri" pitchFamily="34" charset="0"/>
-                <a:ea typeface="Calibri" pitchFamily="34" charset="-122"/>
-                <a:cs typeface="Calibri" pitchFamily="34" charset="-120"/>
-              </a:rPr>
-              <a:t>Use a factor tree: 36 → 6 × 6 → 2×3 × 2×3 = 2² × 3²</a:t>
-            </a:r>
-            <a:endParaRPr lang="en-US" sz="1600" dirty="0"/>
-          </a:p>
-          <a:p>
-            <a:pPr indent="0" marL="0">
-              <a:spcAft>
-                <a:spcPts val="400"/>
-              </a:spcAft>
-              <a:buNone/>
-            </a:pPr>
-            <a:r>
-              <a:rPr lang="en-US" sz="1300" dirty="0">
-                <a:solidFill>
-                  <a:srgbClr val="3D3A36"/>
-                </a:solidFill>
-                <a:latin typeface="Calibri" pitchFamily="34" charset="0"/>
-                <a:ea typeface="Calibri" pitchFamily="34" charset="-122"/>
-                <a:cs typeface="Calibri" pitchFamily="34" charset="-120"/>
-              </a:rPr>
-              <a:t>Every composite number has a unique prime factorisation</a:t>
-            </a:r>
-            <a:endParaRPr lang="en-US" sz="1600" dirty="0"/>
-          </a:p>
-          <a:p>
-            <a:pPr indent="0" marL="0">
-              <a:spcAft>
-                <a:spcPts val="400"/>
-              </a:spcAft>
-              <a:buNone/>
-            </a:pPr>
-            <a:r>
-              <a:rPr lang="en-US" sz="1300" dirty="0">
-                <a:solidFill>
-                  <a:srgbClr val="3D3A36"/>
-                </a:solidFill>
-                <a:latin typeface="Calibri" pitchFamily="34" charset="0"/>
-                <a:ea typeface="Calibri" pitchFamily="34" charset="-122"/>
-                <a:cs typeface="Calibri" pitchFamily="34" charset="-120"/>
-              </a:rPr>
-              <a:t>Useful for finding HCF and LCM efficiently</a:t>
-            </a:r>
-            <a:endParaRPr lang="en-US" sz="1600" dirty="0"/>
-          </a:p>
-          <a:p>
-            <a:pPr indent="0" marL="0">
-              <a:spcAft>
-                <a:spcPts val="400"/>
-              </a:spcAft>
-              <a:buNone/>
-            </a:pPr>
-            <a:r>
-              <a:rPr lang="en-US" sz="1300" dirty="0">
-                <a:solidFill>
-                  <a:srgbClr val="3D3A36"/>
-                </a:solidFill>
-                <a:latin typeface="Calibri" pitchFamily="34" charset="0"/>
-                <a:ea typeface="Calibri" pitchFamily="34" charset="-122"/>
-                <a:cs typeface="Calibri" pitchFamily="34" charset="-120"/>
-              </a:rPr>
-              <a:t>HCF: use the lowest power of common primes</a:t>
-            </a:r>
-            <a:endParaRPr lang="en-US" sz="1600" dirty="0"/>
-          </a:p>
-          <a:p>
-            <a:pPr indent="0" marL="0">
-              <a:spcAft>
-                <a:spcPts val="400"/>
-              </a:spcAft>
-              <a:buNone/>
-            </a:pPr>
-            <a:r>
-              <a:rPr lang="en-US" sz="1300" dirty="0">
-                <a:solidFill>
-                  <a:srgbClr val="3D3A36"/>
-                </a:solidFill>
-                <a:latin typeface="Calibri" pitchFamily="34" charset="0"/>
-                <a:ea typeface="Calibri" pitchFamily="34" charset="-122"/>
-                <a:cs typeface="Calibri" pitchFamily="34" charset="-120"/>
-              </a:rPr>
-              <a:t>LCM: use the highest power of all primes</a:t>
-            </a:r>
-            <a:endParaRPr lang="en-US" sz="1600" dirty="0"/>
+              <a:t>There are infinitely many prime numbers — they go on forever.</a:t>
+            </a:r>
+            <a:endParaRPr lang="en-US" sz="1200" dirty="0"/>
           </a:p>
         </p:txBody>
       </p:sp>
@@ -2649,7 +3427,7 @@
     <p:bg>
       <p:bgPr>
         <a:solidFill>
-          <a:srgbClr val="1B2A4A"/>
+          <a:srgbClr val="FAF8F5"/>
         </a:solidFill>
       </p:bgPr>
     </p:bg>
@@ -2676,27 +3454,67 @@
         <p:spPr>
           <a:xfrm>
             <a:off x="0" y="0"/>
-            <a:ext cx="109728" cy="5143500"/>
-          </a:xfrm>
-          <a:prstGeom prst="rect">
-            <a:avLst/>
-          </a:prstGeom>
-          <a:solidFill>
-            <a:srgbClr val="E9C46A"/>
-          </a:solidFill>
-          <a:ln/>
-        </p:spPr>
-      </p:sp>
-      <p:sp>
-        <p:nvSpPr>
-          <p:cNvPr id="3" name="Text 1"/>
-          <p:cNvSpPr/>
-          <p:nvPr/>
-        </p:nvSpPr>
-        <p:spPr>
-          <a:xfrm>
-            <a:off x="731520" y="457200"/>
-            <a:ext cx="7772400" cy="731520"/>
+            <a:ext cx="9144000" cy="822960"/>
+          </a:xfrm>
+          <a:prstGeom prst="rect">
+            <a:avLst/>
+          </a:prstGeom>
+          <a:solidFill>
+            <a:srgbClr val="FFFFFF"/>
+          </a:solidFill>
+          <a:ln/>
+        </p:spPr>
+      </p:sp>
+      <p:sp>
+        <p:nvSpPr>
+          <p:cNvPr id="3" name="Shape 1"/>
+          <p:cNvSpPr/>
+          <p:nvPr/>
+        </p:nvSpPr>
+        <p:spPr>
+          <a:xfrm>
+            <a:off x="0" y="804672"/>
+            <a:ext cx="9144000" cy="27432"/>
+          </a:xfrm>
+          <a:prstGeom prst="rect">
+            <a:avLst/>
+          </a:prstGeom>
+          <a:solidFill>
+            <a:srgbClr val="E5E2DC"/>
+          </a:solidFill>
+          <a:ln/>
+        </p:spPr>
+      </p:sp>
+      <p:sp>
+        <p:nvSpPr>
+          <p:cNvPr id="4" name="Shape 2"/>
+          <p:cNvSpPr/>
+          <p:nvPr/>
+        </p:nvSpPr>
+        <p:spPr>
+          <a:xfrm>
+            <a:off x="548640" y="201168"/>
+            <a:ext cx="54864" cy="420624"/>
+          </a:xfrm>
+          <a:prstGeom prst="rect">
+            <a:avLst/>
+          </a:prstGeom>
+          <a:solidFill>
+            <a:srgbClr val="2A9D8F"/>
+          </a:solidFill>
+          <a:ln/>
+        </p:spPr>
+      </p:sp>
+      <p:sp>
+        <p:nvSpPr>
+          <p:cNvPr id="5" name="Text 3"/>
+          <p:cNvSpPr/>
+          <p:nvPr/>
+        </p:nvSpPr>
+        <p:spPr>
+          <a:xfrm>
+            <a:off x="777240" y="137160"/>
+            <a:ext cx="7772400" cy="548640"/>
           </a:xfrm>
           <a:prstGeom prst="rect">
             <a:avLst/>
@@ -2705,37 +3523,37 @@
           <a:ln/>
         </p:spPr>
         <p:txBody>
-          <a:bodyPr wrap="square" rtlCol="0" anchor="ctr"/>
+          <a:bodyPr wrap="square" lIns="0" tIns="0" rIns="0" bIns="0" rtlCol="0" anchor="ctr"/>
           <a:lstStyle/>
           <a:p>
             <a:pPr indent="0" marL="0">
               <a:buNone/>
             </a:pPr>
             <a:r>
-              <a:rPr lang="en-US" sz="3200" b="1" dirty="0">
-                <a:solidFill>
-                  <a:srgbClr val="FFFFFF"/>
+              <a:rPr lang="en-US" sz="2000" b="1" dirty="0">
+                <a:solidFill>
+                  <a:srgbClr val="1B2A4A"/>
                 </a:solidFill>
                 <a:latin typeface="Georgia" pitchFamily="34" charset="0"/>
                 <a:ea typeface="Georgia" pitchFamily="34" charset="-122"/>
                 <a:cs typeface="Georgia" pitchFamily="34" charset="-120"/>
               </a:rPr>
-              <a:t>Key Takeaways</a:t>
-            </a:r>
-            <a:endParaRPr lang="en-US" sz="3200" dirty="0"/>
-          </a:p>
-        </p:txBody>
-      </p:sp>
-      <p:sp>
-        <p:nvSpPr>
-          <p:cNvPr id="4" name="Text 2"/>
-          <p:cNvSpPr/>
-          <p:nvPr/>
-        </p:nvSpPr>
-        <p:spPr>
-          <a:xfrm>
-            <a:off x="731520" y="1463040"/>
-            <a:ext cx="7772400" cy="3200400"/>
+              <a:t>HCF and LCM</a:t>
+            </a:r>
+            <a:endParaRPr lang="en-US" sz="2000" dirty="0"/>
+          </a:p>
+        </p:txBody>
+      </p:sp>
+      <p:sp>
+        <p:nvSpPr>
+          <p:cNvPr id="6" name="Text 4"/>
+          <p:cNvSpPr/>
+          <p:nvPr/>
+        </p:nvSpPr>
+        <p:spPr>
+          <a:xfrm>
+            <a:off x="731520" y="1051560"/>
+            <a:ext cx="7680960" cy="3108960"/>
           </a:xfrm>
           <a:prstGeom prst="rect">
             <a:avLst/>
@@ -2749,7 +3567,7 @@
           <a:p>
             <a:pPr marL="342900" indent="-342900">
               <a:spcAft>
-                <a:spcPts val="1000"/>
+                <a:spcPts val="800"/>
               </a:spcAft>
               <a:buSzPct val="100000"/>
               <a:buChar char="•"/>
@@ -2757,20 +3575,20 @@
             <a:r>
               <a:rPr lang="en-US" sz="1500" dirty="0">
                 <a:solidFill>
-                  <a:srgbClr val="CADCFC"/>
+                  <a:srgbClr val="3D3A36"/>
                 </a:solidFill>
                 <a:latin typeface="Calibri" pitchFamily="34" charset="0"/>
                 <a:ea typeface="Calibri" pitchFamily="34" charset="-122"/>
                 <a:cs typeface="Calibri" pitchFamily="34" charset="-120"/>
               </a:rPr>
-              <a:t>Factors: divide exactly into a number. Multiples: times table results</a:t>
+              <a:t>HCF (Highest Common Factor): the LARGEST factor shared by two numbers.</a:t>
             </a:r>
             <a:endParaRPr lang="en-US" sz="1500" dirty="0"/>
           </a:p>
           <a:p>
             <a:pPr marL="342900" indent="-342900">
               <a:spcAft>
-                <a:spcPts val="1000"/>
+                <a:spcPts val="800"/>
               </a:spcAft>
               <a:buSzPct val="100000"/>
               <a:buChar char="•"/>
@@ -2778,20 +3596,20 @@
             <a:r>
               <a:rPr lang="en-US" sz="1500" dirty="0">
                 <a:solidFill>
-                  <a:srgbClr val="CADCFC"/>
+                  <a:srgbClr val="3D3A36"/>
                 </a:solidFill>
                 <a:latin typeface="Calibri" pitchFamily="34" charset="0"/>
                 <a:ea typeface="Calibri" pitchFamily="34" charset="-122"/>
                 <a:cs typeface="Calibri" pitchFamily="34" charset="-120"/>
               </a:rPr>
-              <a:t>Prime: exactly two factors (1 and itself). 1 is NOT prime</a:t>
+              <a:t>HCF of 12 and 18: Factors of 12 = {1,2,3,4,6,12}, Factors of 18 = {1,2,3,6,9,18} → HCF = 6.</a:t>
             </a:r>
             <a:endParaRPr lang="en-US" sz="1500" dirty="0"/>
           </a:p>
           <a:p>
             <a:pPr marL="342900" indent="-342900">
               <a:spcAft>
-                <a:spcPts val="1000"/>
+                <a:spcPts val="800"/>
               </a:spcAft>
               <a:buSzPct val="100000"/>
               <a:buChar char="•"/>
@@ -2799,20 +3617,20 @@
             <a:r>
               <a:rPr lang="en-US" sz="1500" dirty="0">
                 <a:solidFill>
-                  <a:srgbClr val="CADCFC"/>
+                  <a:srgbClr val="3D3A36"/>
                 </a:solidFill>
                 <a:latin typeface="Calibri" pitchFamily="34" charset="0"/>
                 <a:ea typeface="Calibri" pitchFamily="34" charset="-122"/>
                 <a:cs typeface="Calibri" pitchFamily="34" charset="-120"/>
               </a:rPr>
-              <a:t>HCF: highest common factor — largest shared factor</a:t>
+              <a:t>LCM (Lowest Common Multiple): the SMALLEST multiple shared by two numbers.</a:t>
             </a:r>
             <a:endParaRPr lang="en-US" sz="1500" dirty="0"/>
           </a:p>
           <a:p>
             <a:pPr marL="342900" indent="-342900">
               <a:spcAft>
-                <a:spcPts val="1000"/>
+                <a:spcPts val="800"/>
               </a:spcAft>
               <a:buSzPct val="100000"/>
               <a:buChar char="•"/>
@@ -2820,20 +3638,20 @@
             <a:r>
               <a:rPr lang="en-US" sz="1500" dirty="0">
                 <a:solidFill>
-                  <a:srgbClr val="CADCFC"/>
+                  <a:srgbClr val="3D3A36"/>
                 </a:solidFill>
                 <a:latin typeface="Calibri" pitchFamily="34" charset="0"/>
                 <a:ea typeface="Calibri" pitchFamily="34" charset="-122"/>
                 <a:cs typeface="Calibri" pitchFamily="34" charset="-120"/>
               </a:rPr>
-              <a:t>LCM: lowest common multiple — smallest shared multiple</a:t>
+              <a:t>LCM of 4 and 6: Multiples of 4 = {4,8,12,16...}, Multiples of 6 = {6,12,18...} → LCM = 12.</a:t>
             </a:r>
             <a:endParaRPr lang="en-US" sz="1500" dirty="0"/>
           </a:p>
           <a:p>
             <a:pPr marL="342900" indent="-342900">
               <a:spcAft>
-                <a:spcPts val="1000"/>
+                <a:spcPts val="800"/>
               </a:spcAft>
               <a:buSzPct val="100000"/>
               <a:buChar char="•"/>
@@ -2841,18 +3659,110 @@
             <a:r>
               <a:rPr lang="en-US" sz="1500" dirty="0">
                 <a:solidFill>
-                  <a:srgbClr val="CADCFC"/>
+                  <a:srgbClr val="3D3A36"/>
                 </a:solidFill>
                 <a:latin typeface="Calibri" pitchFamily="34" charset="0"/>
                 <a:ea typeface="Calibri" pitchFamily="34" charset="-122"/>
                 <a:cs typeface="Calibri" pitchFamily="34" charset="-120"/>
               </a:rPr>
-              <a:t>Prime factorisation: breaking a number into prime factors using factor trees</a:t>
+              <a:t>HCF is useful for simplifying fractions. LCM is useful for adding fractions.</a:t>
             </a:r>
             <a:endParaRPr lang="en-US" sz="1500" dirty="0"/>
           </a:p>
         </p:txBody>
       </p:sp>
+    </p:spTree>
+  </p:cSld>
+  <p:clrMapOvr>
+    <a:masterClrMapping/>
+  </p:clrMapOvr>
+</p:sld>
+</file>
+
+<file path=ppt/slides/slide6.xml><?xml version="1.0" encoding="utf-8"?>
+<p:sld xmlns:a="http://schemas.openxmlformats.org/drawingml/2006/main" xmlns:r="http://schemas.openxmlformats.org/officeDocument/2006/relationships" xmlns:p="http://schemas.openxmlformats.org/presentationml/2006/main">
+  <p:cSld name="Slide 6">
+    <p:bg>
+      <p:bgPr>
+        <a:solidFill>
+          <a:srgbClr val="FAF8F5"/>
+        </a:solidFill>
+      </p:bgPr>
+    </p:bg>
+    <p:spTree>
+      <p:nvGrpSpPr>
+        <p:cNvPr id="1" name=""/>
+        <p:cNvGrpSpPr/>
+        <p:nvPr/>
+      </p:nvGrpSpPr>
+      <p:grpSpPr>
+        <a:xfrm>
+          <a:off x="0" y="0"/>
+          <a:ext cx="0" cy="0"/>
+          <a:chOff x="0" y="0"/>
+          <a:chExt cx="0" cy="0"/>
+        </a:xfrm>
+      </p:grpSpPr>
+      <p:sp>
+        <p:nvSpPr>
+          <p:cNvPr id="2" name="Shape 0"/>
+          <p:cNvSpPr/>
+          <p:nvPr/>
+        </p:nvSpPr>
+        <p:spPr>
+          <a:xfrm>
+            <a:off x="0" y="0"/>
+            <a:ext cx="9144000" cy="822960"/>
+          </a:xfrm>
+          <a:prstGeom prst="rect">
+            <a:avLst/>
+          </a:prstGeom>
+          <a:solidFill>
+            <a:srgbClr val="FFFFFF"/>
+          </a:solidFill>
+          <a:ln/>
+        </p:spPr>
+      </p:sp>
+      <p:sp>
+        <p:nvSpPr>
+          <p:cNvPr id="3" name="Shape 1"/>
+          <p:cNvSpPr/>
+          <p:nvPr/>
+        </p:nvSpPr>
+        <p:spPr>
+          <a:xfrm>
+            <a:off x="0" y="804672"/>
+            <a:ext cx="9144000" cy="27432"/>
+          </a:xfrm>
+          <a:prstGeom prst="rect">
+            <a:avLst/>
+          </a:prstGeom>
+          <a:solidFill>
+            <a:srgbClr val="E5E2DC"/>
+          </a:solidFill>
+          <a:ln/>
+        </p:spPr>
+      </p:sp>
+      <p:sp>
+        <p:nvSpPr>
+          <p:cNvPr id="4" name="Shape 2"/>
+          <p:cNvSpPr/>
+          <p:nvPr/>
+        </p:nvSpPr>
+        <p:spPr>
+          <a:xfrm>
+            <a:off x="548640" y="201168"/>
+            <a:ext cx="54864" cy="420624"/>
+          </a:xfrm>
+          <a:prstGeom prst="rect">
+            <a:avLst/>
+          </a:prstGeom>
+          <a:solidFill>
+            <a:srgbClr val="2A9D8F"/>
+          </a:solidFill>
+          <a:ln/>
+        </p:spPr>
+      </p:sp>
       <p:sp>
         <p:nvSpPr>
           <p:cNvPr id="5" name="Text 3"/>
@@ -2861,8 +3771,8 @@
         </p:nvSpPr>
         <p:spPr>
           <a:xfrm>
-            <a:off x="731520" y="4572000"/>
-            <a:ext cx="7772400" cy="365760"/>
+            <a:off x="777240" y="137160"/>
+            <a:ext cx="7772400" cy="548640"/>
           </a:xfrm>
           <a:prstGeom prst="rect">
             <a:avLst/>
@@ -2871,24 +3781,783 @@
           <a:ln/>
         </p:spPr>
         <p:txBody>
-          <a:bodyPr wrap="square" rtlCol="0" anchor="ctr"/>
+          <a:bodyPr wrap="square" lIns="0" tIns="0" rIns="0" bIns="0" rtlCol="0" anchor="ctr"/>
           <a:lstStyle/>
           <a:p>
             <a:pPr indent="0" marL="0">
               <a:buNone/>
             </a:pPr>
             <a:r>
-              <a:rPr lang="en-US" sz="1100" dirty="0">
-                <a:solidFill>
-                  <a:srgbClr val="E9C46A"/>
+              <a:rPr lang="en-US" sz="2000" b="1" dirty="0">
+                <a:solidFill>
+                  <a:srgbClr val="1B2A4A"/>
+                </a:solidFill>
+                <a:latin typeface="Georgia" pitchFamily="34" charset="0"/>
+                <a:ea typeface="Georgia" pitchFamily="34" charset="-122"/>
+                <a:cs typeface="Georgia" pitchFamily="34" charset="-120"/>
+              </a:rPr>
+              <a:t>Check Your Understanding</a:t>
+            </a:r>
+            <a:endParaRPr lang="en-US" sz="2000" dirty="0"/>
+          </a:p>
+        </p:txBody>
+      </p:sp>
+      <p:sp>
+        <p:nvSpPr>
+          <p:cNvPr id="6" name="Shape 4"/>
+          <p:cNvSpPr/>
+          <p:nvPr/>
+        </p:nvSpPr>
+        <p:spPr>
+          <a:xfrm>
+            <a:off x="731520" y="1051560"/>
+            <a:ext cx="7680960" cy="438912"/>
+          </a:xfrm>
+          <a:prstGeom prst="rect">
+            <a:avLst/>
+          </a:prstGeom>
+          <a:solidFill>
+            <a:srgbClr val="FFFFFF"/>
+          </a:solidFill>
+          <a:ln/>
+        </p:spPr>
+      </p:sp>
+      <p:sp>
+        <p:nvSpPr>
+          <p:cNvPr id="7" name="Text 5"/>
+          <p:cNvSpPr/>
+          <p:nvPr/>
+        </p:nvSpPr>
+        <p:spPr>
+          <a:xfrm>
+            <a:off x="868680" y="1051560"/>
+            <a:ext cx="320040" cy="438912"/>
+          </a:xfrm>
+          <a:prstGeom prst="rect">
+            <a:avLst/>
+          </a:prstGeom>
+          <a:noFill/>
+          <a:ln/>
+        </p:spPr>
+        <p:txBody>
+          <a:bodyPr wrap="square" rtlCol="0" anchor="ctr"/>
+          <a:lstStyle/>
+          <a:p>
+            <a:pPr indent="0" marL="0">
+              <a:buNone/>
+            </a:pPr>
+            <a:r>
+              <a:rPr lang="en-US" sz="1400" dirty="0">
+                <a:solidFill>
+                  <a:srgbClr val="2A9D8F"/>
+                </a:solidFill>
+              </a:rPr>
+              <a:t>☐</a:t>
+            </a:r>
+            <a:endParaRPr lang="en-US" sz="1400" dirty="0"/>
+          </a:p>
+        </p:txBody>
+      </p:sp>
+      <p:sp>
+        <p:nvSpPr>
+          <p:cNvPr id="8" name="Text 6"/>
+          <p:cNvSpPr/>
+          <p:nvPr/>
+        </p:nvSpPr>
+        <p:spPr>
+          <a:xfrm>
+            <a:off x="1234440" y="1051560"/>
+            <a:ext cx="6949440" cy="438912"/>
+          </a:xfrm>
+          <a:prstGeom prst="rect">
+            <a:avLst/>
+          </a:prstGeom>
+          <a:noFill/>
+          <a:ln/>
+        </p:spPr>
+        <p:txBody>
+          <a:bodyPr wrap="square" rtlCol="0" anchor="ctr"/>
+          <a:lstStyle/>
+          <a:p>
+            <a:pPr indent="0" marL="0">
+              <a:buNone/>
+            </a:pPr>
+            <a:r>
+              <a:rPr lang="en-US" sz="1300" dirty="0">
+                <a:solidFill>
+                  <a:srgbClr val="3D3A36"/>
                 </a:solidFill>
                 <a:latin typeface="Calibri" pitchFamily="34" charset="0"/>
                 <a:ea typeface="Calibri" pitchFamily="34" charset="-122"/>
                 <a:cs typeface="Calibri" pitchFamily="34" charset="-120"/>
               </a:rPr>
+              <a:t>I can find all factors of a number</a:t>
+            </a:r>
+            <a:endParaRPr lang="en-US" sz="1300" dirty="0"/>
+          </a:p>
+        </p:txBody>
+      </p:sp>
+      <p:sp>
+        <p:nvSpPr>
+          <p:cNvPr id="9" name="Shape 7"/>
+          <p:cNvSpPr/>
+          <p:nvPr/>
+        </p:nvSpPr>
+        <p:spPr>
+          <a:xfrm>
+            <a:off x="731520" y="1554480"/>
+            <a:ext cx="7680960" cy="438912"/>
+          </a:xfrm>
+          <a:prstGeom prst="rect">
+            <a:avLst/>
+          </a:prstGeom>
+          <a:solidFill>
+            <a:srgbClr val="F8F6F3"/>
+          </a:solidFill>
+          <a:ln/>
+        </p:spPr>
+      </p:sp>
+      <p:sp>
+        <p:nvSpPr>
+          <p:cNvPr id="10" name="Text 8"/>
+          <p:cNvSpPr/>
+          <p:nvPr/>
+        </p:nvSpPr>
+        <p:spPr>
+          <a:xfrm>
+            <a:off x="868680" y="1554480"/>
+            <a:ext cx="320040" cy="438912"/>
+          </a:xfrm>
+          <a:prstGeom prst="rect">
+            <a:avLst/>
+          </a:prstGeom>
+          <a:noFill/>
+          <a:ln/>
+        </p:spPr>
+        <p:txBody>
+          <a:bodyPr wrap="square" rtlCol="0" anchor="ctr"/>
+          <a:lstStyle/>
+          <a:p>
+            <a:pPr indent="0" marL="0">
+              <a:buNone/>
+            </a:pPr>
+            <a:r>
+              <a:rPr lang="en-US" sz="1400" dirty="0">
+                <a:solidFill>
+                  <a:srgbClr val="2A9D8F"/>
+                </a:solidFill>
+              </a:rPr>
+              <a:t>☐</a:t>
+            </a:r>
+            <a:endParaRPr lang="en-US" sz="1400" dirty="0"/>
+          </a:p>
+        </p:txBody>
+      </p:sp>
+      <p:sp>
+        <p:nvSpPr>
+          <p:cNvPr id="11" name="Text 9"/>
+          <p:cNvSpPr/>
+          <p:nvPr/>
+        </p:nvSpPr>
+        <p:spPr>
+          <a:xfrm>
+            <a:off x="1234440" y="1554480"/>
+            <a:ext cx="6949440" cy="438912"/>
+          </a:xfrm>
+          <a:prstGeom prst="rect">
+            <a:avLst/>
+          </a:prstGeom>
+          <a:noFill/>
+          <a:ln/>
+        </p:spPr>
+        <p:txBody>
+          <a:bodyPr wrap="square" rtlCol="0" anchor="ctr"/>
+          <a:lstStyle/>
+          <a:p>
+            <a:pPr indent="0" marL="0">
+              <a:buNone/>
+            </a:pPr>
+            <a:r>
+              <a:rPr lang="en-US" sz="1300" dirty="0">
+                <a:solidFill>
+                  <a:srgbClr val="3D3A36"/>
+                </a:solidFill>
+                <a:latin typeface="Calibri" pitchFamily="34" charset="0"/>
+                <a:ea typeface="Calibri" pitchFamily="34" charset="-122"/>
+                <a:cs typeface="Calibri" pitchFamily="34" charset="-120"/>
+              </a:rPr>
+              <a:t>I can list multiples of a number</a:t>
+            </a:r>
+            <a:endParaRPr lang="en-US" sz="1300" dirty="0"/>
+          </a:p>
+        </p:txBody>
+      </p:sp>
+      <p:sp>
+        <p:nvSpPr>
+          <p:cNvPr id="12" name="Shape 10"/>
+          <p:cNvSpPr/>
+          <p:nvPr/>
+        </p:nvSpPr>
+        <p:spPr>
+          <a:xfrm>
+            <a:off x="731520" y="2057400"/>
+            <a:ext cx="7680960" cy="438912"/>
+          </a:xfrm>
+          <a:prstGeom prst="rect">
+            <a:avLst/>
+          </a:prstGeom>
+          <a:solidFill>
+            <a:srgbClr val="FFFFFF"/>
+          </a:solidFill>
+          <a:ln/>
+        </p:spPr>
+      </p:sp>
+      <p:sp>
+        <p:nvSpPr>
+          <p:cNvPr id="13" name="Text 11"/>
+          <p:cNvSpPr/>
+          <p:nvPr/>
+        </p:nvSpPr>
+        <p:spPr>
+          <a:xfrm>
+            <a:off x="868680" y="2057400"/>
+            <a:ext cx="320040" cy="438912"/>
+          </a:xfrm>
+          <a:prstGeom prst="rect">
+            <a:avLst/>
+          </a:prstGeom>
+          <a:noFill/>
+          <a:ln/>
+        </p:spPr>
+        <p:txBody>
+          <a:bodyPr wrap="square" rtlCol="0" anchor="ctr"/>
+          <a:lstStyle/>
+          <a:p>
+            <a:pPr indent="0" marL="0">
+              <a:buNone/>
+            </a:pPr>
+            <a:r>
+              <a:rPr lang="en-US" sz="1400" dirty="0">
+                <a:solidFill>
+                  <a:srgbClr val="2A9D8F"/>
+                </a:solidFill>
+              </a:rPr>
+              <a:t>☐</a:t>
+            </a:r>
+            <a:endParaRPr lang="en-US" sz="1400" dirty="0"/>
+          </a:p>
+        </p:txBody>
+      </p:sp>
+      <p:sp>
+        <p:nvSpPr>
+          <p:cNvPr id="14" name="Text 12"/>
+          <p:cNvSpPr/>
+          <p:nvPr/>
+        </p:nvSpPr>
+        <p:spPr>
+          <a:xfrm>
+            <a:off x="1234440" y="2057400"/>
+            <a:ext cx="6949440" cy="438912"/>
+          </a:xfrm>
+          <a:prstGeom prst="rect">
+            <a:avLst/>
+          </a:prstGeom>
+          <a:noFill/>
+          <a:ln/>
+        </p:spPr>
+        <p:txBody>
+          <a:bodyPr wrap="square" rtlCol="0" anchor="ctr"/>
+          <a:lstStyle/>
+          <a:p>
+            <a:pPr indent="0" marL="0">
+              <a:buNone/>
+            </a:pPr>
+            <a:r>
+              <a:rPr lang="en-US" sz="1300" dirty="0">
+                <a:solidFill>
+                  <a:srgbClr val="3D3A36"/>
+                </a:solidFill>
+                <a:latin typeface="Calibri" pitchFamily="34" charset="0"/>
+                <a:ea typeface="Calibri" pitchFamily="34" charset="-122"/>
+                <a:cs typeface="Calibri" pitchFamily="34" charset="-120"/>
+              </a:rPr>
+              <a:t>I can identify prime numbers</a:t>
+            </a:r>
+            <a:endParaRPr lang="en-US" sz="1300" dirty="0"/>
+          </a:p>
+        </p:txBody>
+      </p:sp>
+      <p:sp>
+        <p:nvSpPr>
+          <p:cNvPr id="15" name="Shape 13"/>
+          <p:cNvSpPr/>
+          <p:nvPr/>
+        </p:nvSpPr>
+        <p:spPr>
+          <a:xfrm>
+            <a:off x="731520" y="2560320"/>
+            <a:ext cx="7680960" cy="438912"/>
+          </a:xfrm>
+          <a:prstGeom prst="rect">
+            <a:avLst/>
+          </a:prstGeom>
+          <a:solidFill>
+            <a:srgbClr val="F8F6F3"/>
+          </a:solidFill>
+          <a:ln/>
+        </p:spPr>
+      </p:sp>
+      <p:sp>
+        <p:nvSpPr>
+          <p:cNvPr id="16" name="Text 14"/>
+          <p:cNvSpPr/>
+          <p:nvPr/>
+        </p:nvSpPr>
+        <p:spPr>
+          <a:xfrm>
+            <a:off x="868680" y="2560320"/>
+            <a:ext cx="320040" cy="438912"/>
+          </a:xfrm>
+          <a:prstGeom prst="rect">
+            <a:avLst/>
+          </a:prstGeom>
+          <a:noFill/>
+          <a:ln/>
+        </p:spPr>
+        <p:txBody>
+          <a:bodyPr wrap="square" rtlCol="0" anchor="ctr"/>
+          <a:lstStyle/>
+          <a:p>
+            <a:pPr indent="0" marL="0">
+              <a:buNone/>
+            </a:pPr>
+            <a:r>
+              <a:rPr lang="en-US" sz="1400" dirty="0">
+                <a:solidFill>
+                  <a:srgbClr val="2A9D8F"/>
+                </a:solidFill>
+              </a:rPr>
+              <a:t>☐</a:t>
+            </a:r>
+            <a:endParaRPr lang="en-US" sz="1400" dirty="0"/>
+          </a:p>
+        </p:txBody>
+      </p:sp>
+      <p:sp>
+        <p:nvSpPr>
+          <p:cNvPr id="17" name="Text 15"/>
+          <p:cNvSpPr/>
+          <p:nvPr/>
+        </p:nvSpPr>
+        <p:spPr>
+          <a:xfrm>
+            <a:off x="1234440" y="2560320"/>
+            <a:ext cx="6949440" cy="438912"/>
+          </a:xfrm>
+          <a:prstGeom prst="rect">
+            <a:avLst/>
+          </a:prstGeom>
+          <a:noFill/>
+          <a:ln/>
+        </p:spPr>
+        <p:txBody>
+          <a:bodyPr wrap="square" rtlCol="0" anchor="ctr"/>
+          <a:lstStyle/>
+          <a:p>
+            <a:pPr indent="0" marL="0">
+              <a:buNone/>
+            </a:pPr>
+            <a:r>
+              <a:rPr lang="en-US" sz="1300" dirty="0">
+                <a:solidFill>
+                  <a:srgbClr val="3D3A36"/>
+                </a:solidFill>
+                <a:latin typeface="Calibri" pitchFamily="34" charset="0"/>
+                <a:ea typeface="Calibri" pitchFamily="34" charset="-122"/>
+                <a:cs typeface="Calibri" pitchFamily="34" charset="-120"/>
+              </a:rPr>
+              <a:t>I can find the HCF of two numbers</a:t>
+            </a:r>
+            <a:endParaRPr lang="en-US" sz="1300" dirty="0"/>
+          </a:p>
+        </p:txBody>
+      </p:sp>
+      <p:sp>
+        <p:nvSpPr>
+          <p:cNvPr id="18" name="Shape 16"/>
+          <p:cNvSpPr/>
+          <p:nvPr/>
+        </p:nvSpPr>
+        <p:spPr>
+          <a:xfrm>
+            <a:off x="731520" y="3063240"/>
+            <a:ext cx="7680960" cy="438912"/>
+          </a:xfrm>
+          <a:prstGeom prst="rect">
+            <a:avLst/>
+          </a:prstGeom>
+          <a:solidFill>
+            <a:srgbClr val="FFFFFF"/>
+          </a:solidFill>
+          <a:ln/>
+        </p:spPr>
+      </p:sp>
+      <p:sp>
+        <p:nvSpPr>
+          <p:cNvPr id="19" name="Text 17"/>
+          <p:cNvSpPr/>
+          <p:nvPr/>
+        </p:nvSpPr>
+        <p:spPr>
+          <a:xfrm>
+            <a:off x="868680" y="3063240"/>
+            <a:ext cx="320040" cy="438912"/>
+          </a:xfrm>
+          <a:prstGeom prst="rect">
+            <a:avLst/>
+          </a:prstGeom>
+          <a:noFill/>
+          <a:ln/>
+        </p:spPr>
+        <p:txBody>
+          <a:bodyPr wrap="square" rtlCol="0" anchor="ctr"/>
+          <a:lstStyle/>
+          <a:p>
+            <a:pPr indent="0" marL="0">
+              <a:buNone/>
+            </a:pPr>
+            <a:r>
+              <a:rPr lang="en-US" sz="1400" dirty="0">
+                <a:solidFill>
+                  <a:srgbClr val="2A9D8F"/>
+                </a:solidFill>
+              </a:rPr>
+              <a:t>☐</a:t>
+            </a:r>
+            <a:endParaRPr lang="en-US" sz="1400" dirty="0"/>
+          </a:p>
+        </p:txBody>
+      </p:sp>
+      <p:sp>
+        <p:nvSpPr>
+          <p:cNvPr id="20" name="Text 18"/>
+          <p:cNvSpPr/>
+          <p:nvPr/>
+        </p:nvSpPr>
+        <p:spPr>
+          <a:xfrm>
+            <a:off x="1234440" y="3063240"/>
+            <a:ext cx="6949440" cy="438912"/>
+          </a:xfrm>
+          <a:prstGeom prst="rect">
+            <a:avLst/>
+          </a:prstGeom>
+          <a:noFill/>
+          <a:ln/>
+        </p:spPr>
+        <p:txBody>
+          <a:bodyPr wrap="square" rtlCol="0" anchor="ctr"/>
+          <a:lstStyle/>
+          <a:p>
+            <a:pPr indent="0" marL="0">
+              <a:buNone/>
+            </a:pPr>
+            <a:r>
+              <a:rPr lang="en-US" sz="1300" dirty="0">
+                <a:solidFill>
+                  <a:srgbClr val="3D3A36"/>
+                </a:solidFill>
+                <a:latin typeface="Calibri" pitchFamily="34" charset="0"/>
+                <a:ea typeface="Calibri" pitchFamily="34" charset="-122"/>
+                <a:cs typeface="Calibri" pitchFamily="34" charset="-120"/>
+              </a:rPr>
+              <a:t>I can find the LCM of two numbers</a:t>
+            </a:r>
+            <a:endParaRPr lang="en-US" sz="1300" dirty="0"/>
+          </a:p>
+        </p:txBody>
+      </p:sp>
+      <p:sp>
+        <p:nvSpPr>
+          <p:cNvPr id="21" name="Shape 19"/>
+          <p:cNvSpPr/>
+          <p:nvPr/>
+        </p:nvSpPr>
+        <p:spPr>
+          <a:xfrm>
+            <a:off x="731520" y="3749040"/>
+            <a:ext cx="7680960" cy="594360"/>
+          </a:xfrm>
+          <a:prstGeom prst="rect">
+            <a:avLst/>
+          </a:prstGeom>
+          <a:solidFill>
+            <a:srgbClr val="E8F5F3"/>
+          </a:solidFill>
+          <a:ln/>
+          <a:effectLst>
+            <a:outerShdw sx="100000" sy="100000" kx="0" ky="0" algn="bl" rotWithShape="0" blurRad="50800" dist="25400" dir="8100000">
+              <a:srgbClr val="000000">
+                <a:alpha val="10000"/>
+              </a:srgbClr>
+            </a:outerShdw>
+          </a:effectLst>
+        </p:spPr>
+      </p:sp>
+      <p:sp>
+        <p:nvSpPr>
+          <p:cNvPr id="22" name="Text 20"/>
+          <p:cNvSpPr/>
+          <p:nvPr/>
+        </p:nvSpPr>
+        <p:spPr>
+          <a:xfrm>
+            <a:off x="914400" y="3749040"/>
+            <a:ext cx="7315200" cy="594360"/>
+          </a:xfrm>
+          <a:prstGeom prst="rect">
+            <a:avLst/>
+          </a:prstGeom>
+          <a:noFill/>
+          <a:ln/>
+        </p:spPr>
+        <p:txBody>
+          <a:bodyPr wrap="square" rtlCol="0" anchor="ctr"/>
+          <a:lstStyle/>
+          <a:p>
+            <a:pPr indent="0" marL="0">
+              <a:buNone/>
+            </a:pPr>
+            <a:r>
+              <a:rPr lang="en-US" sz="1200" b="1" dirty="0">
+                <a:solidFill>
+                  <a:srgbClr val="2A9D8F"/>
+                </a:solidFill>
+                <a:latin typeface="Calibri" pitchFamily="34" charset="0"/>
+                <a:ea typeface="Calibri" pitchFamily="34" charset="-122"/>
+                <a:cs typeface="Calibri" pitchFamily="34" charset="-120"/>
+              </a:rPr>
+              <a:t>Key Idea: </a:t>
+            </a:r>
+            <a:pPr indent="0" marL="0">
+              <a:buNone/>
+            </a:pPr>
+            <a:r>
+              <a:rPr lang="en-US" sz="1200" i="1" dirty="0">
+                <a:solidFill>
+                  <a:srgbClr val="3D3A36"/>
+                </a:solidFill>
+                <a:latin typeface="Calibri" pitchFamily="34" charset="0"/>
+                <a:ea typeface="Calibri" pitchFamily="34" charset="-122"/>
+                <a:cs typeface="Calibri" pitchFamily="34" charset="-120"/>
+              </a:rPr>
+              <a:t>Factors divide IN, multiples multiply OUT, primes have exactly 2 factors.</a:t>
+            </a:r>
+            <a:endParaRPr lang="en-US" sz="1200" dirty="0"/>
+          </a:p>
+        </p:txBody>
+      </p:sp>
+    </p:spTree>
+  </p:cSld>
+  <p:clrMapOvr>
+    <a:masterClrMapping/>
+  </p:clrMapOvr>
+</p:sld>
+</file>
+
+<file path=ppt/slides/slide7.xml><?xml version="1.0" encoding="utf-8"?>
+<p:sld xmlns:a="http://schemas.openxmlformats.org/drawingml/2006/main" xmlns:r="http://schemas.openxmlformats.org/officeDocument/2006/relationships" xmlns:p="http://schemas.openxmlformats.org/presentationml/2006/main">
+  <p:cSld name="Slide 7">
+    <p:spTree>
+      <p:nvGrpSpPr>
+        <p:cNvPr id="1" name=""/>
+        <p:cNvGrpSpPr/>
+        <p:nvPr/>
+      </p:nvGrpSpPr>
+      <p:grpSpPr>
+        <a:xfrm>
+          <a:off x="0" y="0"/>
+          <a:ext cx="0" cy="0"/>
+          <a:chOff x="0" y="0"/>
+          <a:chExt cx="0" cy="0"/>
+        </a:xfrm>
+      </p:grpSpPr>
+      <p:sp>
+        <p:nvSpPr>
+          <p:cNvPr id="2" name="Shape 0"/>
+          <p:cNvSpPr/>
+          <p:nvPr/>
+        </p:nvSpPr>
+        <p:spPr>
+          <a:xfrm>
+            <a:off x="0" y="0"/>
+            <a:ext cx="9144000" cy="5143500"/>
+          </a:xfrm>
+          <a:prstGeom prst="rect">
+            <a:avLst/>
+          </a:prstGeom>
+          <a:solidFill>
+            <a:srgbClr val="1B2A4A"/>
+          </a:solidFill>
+          <a:ln/>
+        </p:spPr>
+      </p:sp>
+      <p:sp>
+        <p:nvSpPr>
+          <p:cNvPr id="3" name="Shape 1"/>
+          <p:cNvSpPr/>
+          <p:nvPr/>
+        </p:nvSpPr>
+        <p:spPr>
+          <a:xfrm>
+            <a:off x="0" y="4777740"/>
+            <a:ext cx="9144000" cy="365760"/>
+          </a:xfrm>
+          <a:prstGeom prst="rect">
+            <a:avLst/>
+          </a:prstGeom>
+          <a:solidFill>
+            <a:srgbClr val="2A9D8F"/>
+          </a:solidFill>
+          <a:ln/>
+        </p:spPr>
+      </p:sp>
+      <p:sp>
+        <p:nvSpPr>
+          <p:cNvPr id="4" name="Shape 2"/>
+          <p:cNvSpPr/>
+          <p:nvPr/>
+        </p:nvSpPr>
+        <p:spPr>
+          <a:xfrm>
+            <a:off x="-914400" y="-914400"/>
+            <a:ext cx="3657600" cy="3657600"/>
+          </a:xfrm>
+          <a:prstGeom prst="ellipse">
+            <a:avLst/>
+          </a:prstGeom>
+          <a:solidFill>
+            <a:srgbClr val="2A9D8F">
+              <a:alpha val="10000"/>
+            </a:srgbClr>
+          </a:solidFill>
+          <a:ln/>
+        </p:spPr>
+      </p:sp>
+      <p:sp>
+        <p:nvSpPr>
+          <p:cNvPr id="5" name="Text 3"/>
+          <p:cNvSpPr/>
+          <p:nvPr/>
+        </p:nvSpPr>
+        <p:spPr>
+          <a:xfrm>
+            <a:off x="731520" y="1463040"/>
+            <a:ext cx="7680960" cy="822960"/>
+          </a:xfrm>
+          <a:prstGeom prst="rect">
+            <a:avLst/>
+          </a:prstGeom>
+          <a:noFill/>
+          <a:ln/>
+        </p:spPr>
+        <p:txBody>
+          <a:bodyPr wrap="square" rtlCol="0" anchor="ctr"/>
+          <a:lstStyle/>
+          <a:p>
+            <a:pPr algn="ctr" indent="0" marL="0">
+              <a:buNone/>
+            </a:pPr>
+            <a:r>
+              <a:rPr lang="en-US" sz="3400" b="1" dirty="0">
+                <a:solidFill>
+                  <a:srgbClr val="FFFFFF"/>
+                </a:solidFill>
+                <a:latin typeface="Georgia" pitchFamily="34" charset="0"/>
+                <a:ea typeface="Georgia" pitchFamily="34" charset="-122"/>
+                <a:cs typeface="Georgia" pitchFamily="34" charset="-120"/>
+              </a:rPr>
+              <a:t>Review &amp; Practise</a:t>
+            </a:r>
+            <a:endParaRPr lang="en-US" sz="3400" dirty="0"/>
+          </a:p>
+        </p:txBody>
+      </p:sp>
+      <p:sp>
+        <p:nvSpPr>
+          <p:cNvPr id="6" name="Text 4"/>
+          <p:cNvSpPr/>
+          <p:nvPr/>
+        </p:nvSpPr>
+        <p:spPr>
+          <a:xfrm>
+            <a:off x="731520" y="2468880"/>
+            <a:ext cx="7680960" cy="457200"/>
+          </a:xfrm>
+          <a:prstGeom prst="rect">
+            <a:avLst/>
+          </a:prstGeom>
+          <a:noFill/>
+          <a:ln/>
+        </p:spPr>
+        <p:txBody>
+          <a:bodyPr wrap="square" rtlCol="0" anchor="ctr"/>
+          <a:lstStyle/>
+          <a:p>
+            <a:pPr algn="ctr" indent="0" marL="0">
+              <a:buNone/>
+            </a:pPr>
+            <a:r>
+              <a:rPr lang="en-US" sz="1800" dirty="0">
+                <a:solidFill>
+                  <a:srgbClr val="2A9D8F"/>
+                </a:solidFill>
+                <a:latin typeface="Calibri" pitchFamily="34" charset="0"/>
+                <a:ea typeface="Calibri" pitchFamily="34" charset="-122"/>
+                <a:cs typeface="Calibri" pitchFamily="34" charset="-120"/>
+              </a:rPr>
               <a:t>mrzocchi.com</a:t>
             </a:r>
-            <a:endParaRPr lang="en-US" sz="1100" dirty="0"/>
+            <a:endParaRPr lang="en-US" sz="1800" dirty="0"/>
+          </a:p>
+        </p:txBody>
+      </p:sp>
+      <p:sp>
+        <p:nvSpPr>
+          <p:cNvPr id="7" name="Text 5"/>
+          <p:cNvSpPr/>
+          <p:nvPr/>
+        </p:nvSpPr>
+        <p:spPr>
+          <a:xfrm>
+            <a:off x="731520" y="3108960"/>
+            <a:ext cx="7680960" cy="457200"/>
+          </a:xfrm>
+          <a:prstGeom prst="rect">
+            <a:avLst/>
+          </a:prstGeom>
+          <a:noFill/>
+          <a:ln/>
+        </p:spPr>
+        <p:txBody>
+          <a:bodyPr wrap="square" rtlCol="0" anchor="ctr"/>
+          <a:lstStyle/>
+          <a:p>
+            <a:pPr algn="ctr" indent="0" marL="0">
+              <a:buNone/>
+            </a:pPr>
+            <a:r>
+              <a:rPr lang="en-US" sz="1300" dirty="0">
+                <a:solidFill>
+                  <a:srgbClr val="9B9690"/>
+                </a:solidFill>
+                <a:latin typeface="Calibri" pitchFamily="34" charset="0"/>
+                <a:ea typeface="Calibri" pitchFamily="34" charset="-122"/>
+                <a:cs typeface="Calibri" pitchFamily="34" charset="-120"/>
+              </a:rPr>
+              <a:t>Use the Self-Quiz, Review Games, and Practice Builder to test yourself.</a:t>
+            </a:r>
+            <a:endParaRPr lang="en-US" sz="1300" dirty="0"/>
           </a:p>
         </p:txBody>
       </p:sp>

</xml_diff>